<commit_message>
Presentacion por region: agregar division por provincias y bancos por provincia
Co-Authored-By: Claude Sonnet 5.5 <noreply@anthropic.com>
</commit_message>
<xml_diff>
--- a/datos/Bancos_de_sangre_por_region.pptx
+++ b/datos/Bancos_de_sangre_por_region.pptx
@@ -635,7 +635,7 @@
                 </a:solidFill>
                 <a:latin typeface="Calibri"/>
               </a:rPr>
-              <a:t>Cajamarca · ubicación de los bancos de sangre</a:t>
+              <a:t>Cajamarca · provincias y ubicación de los bancos de sangre</a:t>
             </a:r>
           </a:p>
         </p:txBody>
@@ -672,8 +672,8 @@
         </p:nvSpPr>
         <p:spPr>
           <a:xfrm>
-            <a:off x="8100000" y="1000000"/>
-            <a:ext cx="3800000" cy="5700000"/>
+            <a:off x="8100000" y="950000"/>
+            <a:ext cx="3900000" cy="5800000"/>
           </a:xfrm>
           <a:prstGeom prst="rect">
             <a:avLst/>
@@ -704,7 +704,7 @@
               <a:buChar char="•"/>
             </a:pPr>
             <a:r>
-              <a:rPr lang="es-PE" sz="1700" dirty="0">
+              <a:rPr lang="es-PE" sz="1600" dirty="0">
                 <a:solidFill>
                   <a:srgbClr val="C2334D"/>
                 </a:solidFill>
@@ -719,7 +719,7 @@
               <a:buChar char="•"/>
             </a:pPr>
             <a:r>
-              <a:rPr lang="es-PE" sz="1700" dirty="0">
+              <a:rPr lang="es-PE" sz="1600" dirty="0">
                 <a:solidFill>
                   <a:srgbClr val="1F6F8B"/>
                 </a:solidFill>
@@ -734,7 +734,7 @@
               <a:buChar char="•"/>
             </a:pPr>
             <a:r>
-              <a:rPr lang="es-PE" sz="1700" dirty="0">
+              <a:rPr lang="es-PE" sz="1600" dirty="0">
                 <a:solidFill>
                   <a:srgbClr val="B7791F"/>
                 </a:solidFill>
@@ -749,7 +749,7 @@
               <a:buChar char="•"/>
             </a:pPr>
             <a:r>
-              <a:rPr lang="es-PE" sz="1700" dirty="0">
+              <a:rPr lang="es-PE" sz="1600" dirty="0">
                 <a:solidFill>
                   <a:srgbClr val="2F6B3F"/>
                 </a:solidFill>
@@ -763,13 +763,13 @@
               <a:buNone/>
             </a:pPr>
             <a:r>
-              <a:rPr lang="es-PE" sz="1400" b="1" dirty="0">
+              <a:rPr lang="es-PE" sz="1300" b="1" dirty="0">
                 <a:solidFill>
                   <a:srgbClr val="445066"/>
                 </a:solidFill>
                 <a:latin typeface="Calibri"/>
               </a:rPr>
-              <a:t>Principales provincias</a:t>
+              <a:t>Provincias: 13 (con banco: 6)</a:t>
             </a:r>
           </a:p>
           <a:p>
@@ -799,7 +799,7 @@
                 </a:solidFill>
                 <a:latin typeface="Calibri"/>
               </a:rPr>
-              <a:t>Cajamarca: 7</a:t>
+              <a:t>Cajamarca: 6</a:t>
             </a:r>
           </a:p>
           <a:p>
@@ -844,6 +844,21 @@
                 </a:solidFill>
                 <a:latin typeface="Calibri"/>
               </a:rPr>
+              <a:t>Cajabamba: 1</a:t>
+            </a:r>
+          </a:p>
+          <a:p>
+            <a:pPr marL="0" indent="0">
+              <a:buFont typeface="Arial"/>
+              <a:buChar char="•"/>
+            </a:pPr>
+            <a:r>
+              <a:rPr lang="es-PE" sz="1200" dirty="0">
+                <a:solidFill>
+                  <a:srgbClr val="223344"/>
+                </a:solidFill>
+                <a:latin typeface="Calibri"/>
+              </a:rPr>
               <a:t>Celendin: 1</a:t>
             </a:r>
           </a:p>
@@ -858,7 +873,21 @@
                 </a:solidFill>
                 <a:latin typeface="Calibri"/>
               </a:rPr>
-              <a:t>Círculo = tipo I · cuadrado = tipo II. Ubicación aproximada al distrito declarado.</a:t>
+              <a:t>Sin bancos: Contumaza, Hualgayoc, San Ignacio, San Marcos, San Miguel, San Pablo, Santa Cruz</a:t>
+            </a:r>
+          </a:p>
+          <a:p>
+            <a:pPr marL="0" indent="0">
+              <a:buNone/>
+            </a:pPr>
+            <a:r>
+              <a:rPr lang="es-PE" sz="900" dirty="0">
+                <a:solidFill>
+                  <a:srgbClr val="7A8699"/>
+                </a:solidFill>
+                <a:latin typeface="Calibri"/>
+              </a:rPr>
+              <a:t>Círculo = tipo I · cuadrado = tipo II · el número es la cantidad de bancos en un mismo punto. Ubicación aproximada al distrito declarado.</a:t>
             </a:r>
           </a:p>
         </p:txBody>
@@ -919,7 +948,7 @@
                 </a:solidFill>
                 <a:latin typeface="Calibri"/>
               </a:rPr>
-              <a:t>Callao · ubicación de los bancos de sangre</a:t>
+              <a:t>Callao · provincias y ubicación de los bancos de sangre</a:t>
             </a:r>
           </a:p>
         </p:txBody>
@@ -956,8 +985,8 @@
         </p:nvSpPr>
         <p:spPr>
           <a:xfrm>
-            <a:off x="8100000" y="1000000"/>
-            <a:ext cx="3800000" cy="5700000"/>
+            <a:off x="8100000" y="950000"/>
+            <a:ext cx="3900000" cy="5800000"/>
           </a:xfrm>
           <a:prstGeom prst="rect">
             <a:avLst/>
@@ -988,7 +1017,7 @@
               <a:buChar char="•"/>
             </a:pPr>
             <a:r>
-              <a:rPr lang="es-PE" sz="1700" dirty="0">
+              <a:rPr lang="es-PE" sz="1600" dirty="0">
                 <a:solidFill>
                   <a:srgbClr val="C2334D"/>
                 </a:solidFill>
@@ -1003,7 +1032,7 @@
               <a:buChar char="•"/>
             </a:pPr>
             <a:r>
-              <a:rPr lang="es-PE" sz="1700" dirty="0">
+              <a:rPr lang="es-PE" sz="1600" dirty="0">
                 <a:solidFill>
                   <a:srgbClr val="1F6F8B"/>
                 </a:solidFill>
@@ -1018,7 +1047,7 @@
               <a:buChar char="•"/>
             </a:pPr>
             <a:r>
-              <a:rPr lang="es-PE" sz="1700" dirty="0">
+              <a:rPr lang="es-PE" sz="1600" dirty="0">
                 <a:solidFill>
                   <a:srgbClr val="B7791F"/>
                 </a:solidFill>
@@ -1033,7 +1062,7 @@
               <a:buChar char="•"/>
             </a:pPr>
             <a:r>
-              <a:rPr lang="es-PE" sz="1700" dirty="0">
+              <a:rPr lang="es-PE" sz="1600" dirty="0">
                 <a:solidFill>
                   <a:srgbClr val="2F6B3F"/>
                 </a:solidFill>
@@ -1047,13 +1076,13 @@
               <a:buNone/>
             </a:pPr>
             <a:r>
-              <a:rPr lang="es-PE" sz="1400" b="1" dirty="0">
+              <a:rPr lang="es-PE" sz="1300" b="1" dirty="0">
                 <a:solidFill>
                   <a:srgbClr val="445066"/>
                 </a:solidFill>
                 <a:latin typeface="Calibri"/>
               </a:rPr>
-              <a:t>Principales provincias</a:t>
+              <a:t>Provincias: 1 (con banco: 1)</a:t>
             </a:r>
           </a:p>
           <a:p>
@@ -1076,13 +1105,13 @@
               <a:buNone/>
             </a:pPr>
             <a:r>
-              <a:rPr lang="es-PE" sz="1000" dirty="0">
+              <a:rPr lang="es-PE" sz="900" dirty="0">
                 <a:solidFill>
                   <a:srgbClr val="7A8699"/>
                 </a:solidFill>
                 <a:latin typeface="Calibri"/>
               </a:rPr>
-              <a:t>Círculo = tipo I · cuadrado = tipo II. Ubicación aproximada al distrito declarado.</a:t>
+              <a:t>Círculo = tipo I · cuadrado = tipo II · el número es la cantidad de bancos en un mismo punto. Ubicación aproximada al distrito declarado.</a:t>
             </a:r>
           </a:p>
         </p:txBody>
@@ -1143,7 +1172,7 @@
                 </a:solidFill>
                 <a:latin typeface="Calibri"/>
               </a:rPr>
-              <a:t>Cusco · ubicación de los bancos de sangre</a:t>
+              <a:t>Cusco · provincias y ubicación de los bancos de sangre</a:t>
             </a:r>
           </a:p>
         </p:txBody>
@@ -1180,8 +1209,8 @@
         </p:nvSpPr>
         <p:spPr>
           <a:xfrm>
-            <a:off x="8100000" y="1000000"/>
-            <a:ext cx="3800000" cy="5700000"/>
+            <a:off x="8100000" y="950000"/>
+            <a:ext cx="3900000" cy="5800000"/>
           </a:xfrm>
           <a:prstGeom prst="rect">
             <a:avLst/>
@@ -1212,7 +1241,7 @@
               <a:buChar char="•"/>
             </a:pPr>
             <a:r>
-              <a:rPr lang="es-PE" sz="1700" dirty="0">
+              <a:rPr lang="es-PE" sz="1600" dirty="0">
                 <a:solidFill>
                   <a:srgbClr val="C2334D"/>
                 </a:solidFill>
@@ -1227,7 +1256,7 @@
               <a:buChar char="•"/>
             </a:pPr>
             <a:r>
-              <a:rPr lang="es-PE" sz="1700" dirty="0">
+              <a:rPr lang="es-PE" sz="1600" dirty="0">
                 <a:solidFill>
                   <a:srgbClr val="1F6F8B"/>
                 </a:solidFill>
@@ -1242,7 +1271,7 @@
               <a:buChar char="•"/>
             </a:pPr>
             <a:r>
-              <a:rPr lang="es-PE" sz="1700" dirty="0">
+              <a:rPr lang="es-PE" sz="1600" dirty="0">
                 <a:solidFill>
                   <a:srgbClr val="B7791F"/>
                 </a:solidFill>
@@ -1257,7 +1286,7 @@
               <a:buChar char="•"/>
             </a:pPr>
             <a:r>
-              <a:rPr lang="es-PE" sz="1700" dirty="0">
+              <a:rPr lang="es-PE" sz="1600" dirty="0">
                 <a:solidFill>
                   <a:srgbClr val="2F6B3F"/>
                 </a:solidFill>
@@ -1271,13 +1300,13 @@
               <a:buNone/>
             </a:pPr>
             <a:r>
-              <a:rPr lang="es-PE" sz="1400" b="1" dirty="0">
+              <a:rPr lang="es-PE" sz="1300" b="1" dirty="0">
                 <a:solidFill>
                   <a:srgbClr val="445066"/>
                 </a:solidFill>
                 <a:latin typeface="Calibri"/>
               </a:rPr>
-              <a:t>Principales provincias</a:t>
+              <a:t>Provincias: 13 (con banco: 5)</a:t>
             </a:r>
           </a:p>
           <a:p>
@@ -1307,7 +1336,7 @@
                 </a:solidFill>
                 <a:latin typeface="Calibri"/>
               </a:rPr>
-              <a:t>La Convencion: 4</a:t>
+              <a:t>La Convencion: 5</a:t>
             </a:r>
           </a:p>
           <a:p>
@@ -1322,6 +1351,21 @@
                 </a:solidFill>
                 <a:latin typeface="Calibri"/>
               </a:rPr>
+              <a:t>Canchis: 2</a:t>
+            </a:r>
+          </a:p>
+          <a:p>
+            <a:pPr marL="0" indent="0">
+              <a:buFont typeface="Arial"/>
+              <a:buChar char="•"/>
+            </a:pPr>
+            <a:r>
+              <a:rPr lang="es-PE" sz="1200" dirty="0">
+                <a:solidFill>
+                  <a:srgbClr val="223344"/>
+                </a:solidFill>
+                <a:latin typeface="Calibri"/>
+              </a:rPr>
               <a:t>Espinar: 2</a:t>
             </a:r>
           </a:p>
@@ -1337,36 +1381,6 @@
                 </a:solidFill>
                 <a:latin typeface="Calibri"/>
               </a:rPr>
-              <a:t>Canchis: 2</a:t>
-            </a:r>
-          </a:p>
-          <a:p>
-            <a:pPr marL="0" indent="0">
-              <a:buFont typeface="Arial"/>
-              <a:buChar char="•"/>
-            </a:pPr>
-            <a:r>
-              <a:rPr lang="es-PE" sz="1200" dirty="0">
-                <a:solidFill>
-                  <a:srgbClr val="223344"/>
-                </a:solidFill>
-                <a:latin typeface="Calibri"/>
-              </a:rPr>
-              <a:t>La Convencios: 1</a:t>
-            </a:r>
-          </a:p>
-          <a:p>
-            <a:pPr marL="0" indent="0">
-              <a:buFont typeface="Arial"/>
-              <a:buChar char="•"/>
-            </a:pPr>
-            <a:r>
-              <a:rPr lang="es-PE" sz="1200" dirty="0">
-                <a:solidFill>
-                  <a:srgbClr val="223344"/>
-                </a:solidFill>
-                <a:latin typeface="Calibri"/>
-              </a:rPr>
               <a:t>Chumbivilcas: 1</a:t>
             </a:r>
           </a:p>
@@ -1381,7 +1395,21 @@
                 </a:solidFill>
                 <a:latin typeface="Calibri"/>
               </a:rPr>
-              <a:t>Círculo = tipo I · cuadrado = tipo II. Ubicación aproximada al distrito declarado.</a:t>
+              <a:t>Sin bancos: Acomayo, Anta, Calca, Canas, Paruro, Paucartambo, Quispicanchi, Urubamba</a:t>
+            </a:r>
+          </a:p>
+          <a:p>
+            <a:pPr marL="0" indent="0">
+              <a:buNone/>
+            </a:pPr>
+            <a:r>
+              <a:rPr lang="es-PE" sz="900" dirty="0">
+                <a:solidFill>
+                  <a:srgbClr val="7A8699"/>
+                </a:solidFill>
+                <a:latin typeface="Calibri"/>
+              </a:rPr>
+              <a:t>Círculo = tipo I · cuadrado = tipo II · el número es la cantidad de bancos en un mismo punto. Ubicación aproximada al distrito declarado.</a:t>
             </a:r>
           </a:p>
         </p:txBody>
@@ -1442,7 +1470,7 @@
                 </a:solidFill>
                 <a:latin typeface="Calibri"/>
               </a:rPr>
-              <a:t>Huancavelica · ubicación de los bancos de sangre</a:t>
+              <a:t>Huancavelica · provincias y ubicación de los bancos de sangre</a:t>
             </a:r>
           </a:p>
         </p:txBody>
@@ -1479,8 +1507,8 @@
         </p:nvSpPr>
         <p:spPr>
           <a:xfrm>
-            <a:off x="8100000" y="1000000"/>
-            <a:ext cx="3800000" cy="5700000"/>
+            <a:off x="8100000" y="950000"/>
+            <a:ext cx="3900000" cy="5800000"/>
           </a:xfrm>
           <a:prstGeom prst="rect">
             <a:avLst/>
@@ -1511,7 +1539,7 @@
               <a:buChar char="•"/>
             </a:pPr>
             <a:r>
-              <a:rPr lang="es-PE" sz="1700" dirty="0">
+              <a:rPr lang="es-PE" sz="1600" dirty="0">
                 <a:solidFill>
                   <a:srgbClr val="C2334D"/>
                 </a:solidFill>
@@ -1526,7 +1554,7 @@
               <a:buChar char="•"/>
             </a:pPr>
             <a:r>
-              <a:rPr lang="es-PE" sz="1700" dirty="0">
+              <a:rPr lang="es-PE" sz="1600" dirty="0">
                 <a:solidFill>
                   <a:srgbClr val="1F6F8B"/>
                 </a:solidFill>
@@ -1541,7 +1569,7 @@
               <a:buChar char="•"/>
             </a:pPr>
             <a:r>
-              <a:rPr lang="es-PE" sz="1700" dirty="0">
+              <a:rPr lang="es-PE" sz="1600" dirty="0">
                 <a:solidFill>
                   <a:srgbClr val="B7791F"/>
                 </a:solidFill>
@@ -1556,7 +1584,7 @@
               <a:buChar char="•"/>
             </a:pPr>
             <a:r>
-              <a:rPr lang="es-PE" sz="1700" dirty="0">
+              <a:rPr lang="es-PE" sz="1600" dirty="0">
                 <a:solidFill>
                   <a:srgbClr val="2F6B3F"/>
                 </a:solidFill>
@@ -1570,13 +1598,13 @@
               <a:buNone/>
             </a:pPr>
             <a:r>
-              <a:rPr lang="es-PE" sz="1400" b="1" dirty="0">
+              <a:rPr lang="es-PE" sz="1300" b="1" dirty="0">
                 <a:solidFill>
                   <a:srgbClr val="445066"/>
                 </a:solidFill>
                 <a:latin typeface="Calibri"/>
               </a:rPr>
-              <a:t>Principales provincias</a:t>
+              <a:t>Provincias: 7 (con banco: 4)</a:t>
             </a:r>
           </a:p>
           <a:p>
@@ -1606,6 +1634,21 @@
                 </a:solidFill>
                 <a:latin typeface="Calibri"/>
               </a:rPr>
+              <a:t>Acobamba: 1</a:t>
+            </a:r>
+          </a:p>
+          <a:p>
+            <a:pPr marL="0" indent="0">
+              <a:buFont typeface="Arial"/>
+              <a:buChar char="•"/>
+            </a:pPr>
+            <a:r>
+              <a:rPr lang="es-PE" sz="1200" dirty="0">
+                <a:solidFill>
+                  <a:srgbClr val="223344"/>
+                </a:solidFill>
+                <a:latin typeface="Calibri"/>
+              </a:rPr>
               <a:t>Angaraes: 1</a:t>
             </a:r>
           </a:p>
@@ -1621,21 +1664,6 @@
                 </a:solidFill>
                 <a:latin typeface="Calibri"/>
               </a:rPr>
-              <a:t>Acobamba: 1</a:t>
-            </a:r>
-          </a:p>
-          <a:p>
-            <a:pPr marL="0" indent="0">
-              <a:buFont typeface="Arial"/>
-              <a:buChar char="•"/>
-            </a:pPr>
-            <a:r>
-              <a:rPr lang="es-PE" sz="1200" dirty="0">
-                <a:solidFill>
-                  <a:srgbClr val="223344"/>
-                </a:solidFill>
-                <a:latin typeface="Calibri"/>
-              </a:rPr>
               <a:t>Tayacaja: 1</a:t>
             </a:r>
           </a:p>
@@ -1650,7 +1678,21 @@
                 </a:solidFill>
                 <a:latin typeface="Calibri"/>
               </a:rPr>
-              <a:t>Círculo = tipo I · cuadrado = tipo II. Ubicación aproximada al distrito declarado.</a:t>
+              <a:t>Sin bancos: Castrovirreyna, Churcampa, Huaytara</a:t>
+            </a:r>
+          </a:p>
+          <a:p>
+            <a:pPr marL="0" indent="0">
+              <a:buNone/>
+            </a:pPr>
+            <a:r>
+              <a:rPr lang="es-PE" sz="900" dirty="0">
+                <a:solidFill>
+                  <a:srgbClr val="7A8699"/>
+                </a:solidFill>
+                <a:latin typeface="Calibri"/>
+              </a:rPr>
+              <a:t>Círculo = tipo I · cuadrado = tipo II · el número es la cantidad de bancos en un mismo punto. Ubicación aproximada al distrito declarado.</a:t>
             </a:r>
           </a:p>
         </p:txBody>
@@ -1711,7 +1753,7 @@
                 </a:solidFill>
                 <a:latin typeface="Calibri"/>
               </a:rPr>
-              <a:t>Huánuco · ubicación de los bancos de sangre</a:t>
+              <a:t>Huánuco · provincias y ubicación de los bancos de sangre</a:t>
             </a:r>
           </a:p>
         </p:txBody>
@@ -1748,8 +1790,8 @@
         </p:nvSpPr>
         <p:spPr>
           <a:xfrm>
-            <a:off x="8100000" y="1000000"/>
-            <a:ext cx="3800000" cy="5700000"/>
+            <a:off x="8100000" y="950000"/>
+            <a:ext cx="3900000" cy="5800000"/>
           </a:xfrm>
           <a:prstGeom prst="rect">
             <a:avLst/>
@@ -1780,7 +1822,7 @@
               <a:buChar char="•"/>
             </a:pPr>
             <a:r>
-              <a:rPr lang="es-PE" sz="1700" dirty="0">
+              <a:rPr lang="es-PE" sz="1600" dirty="0">
                 <a:solidFill>
                   <a:srgbClr val="C2334D"/>
                 </a:solidFill>
@@ -1795,7 +1837,7 @@
               <a:buChar char="•"/>
             </a:pPr>
             <a:r>
-              <a:rPr lang="es-PE" sz="1700" dirty="0">
+              <a:rPr lang="es-PE" sz="1600" dirty="0">
                 <a:solidFill>
                   <a:srgbClr val="1F6F8B"/>
                 </a:solidFill>
@@ -1810,7 +1852,7 @@
               <a:buChar char="•"/>
             </a:pPr>
             <a:r>
-              <a:rPr lang="es-PE" sz="1700" dirty="0">
+              <a:rPr lang="es-PE" sz="1600" dirty="0">
                 <a:solidFill>
                   <a:srgbClr val="B7791F"/>
                 </a:solidFill>
@@ -1825,7 +1867,7 @@
               <a:buChar char="•"/>
             </a:pPr>
             <a:r>
-              <a:rPr lang="es-PE" sz="1700" dirty="0">
+              <a:rPr lang="es-PE" sz="1600" dirty="0">
                 <a:solidFill>
                   <a:srgbClr val="2F6B3F"/>
                 </a:solidFill>
@@ -1839,13 +1881,13 @@
               <a:buNone/>
             </a:pPr>
             <a:r>
-              <a:rPr lang="es-PE" sz="1400" b="1" dirty="0">
+              <a:rPr lang="es-PE" sz="1300" b="1" dirty="0">
                 <a:solidFill>
                   <a:srgbClr val="445066"/>
                 </a:solidFill>
                 <a:latin typeface="Calibri"/>
               </a:rPr>
-              <a:t>Principales provincias</a:t>
+              <a:t>Provincias: 11 (con banco: 3)</a:t>
             </a:r>
           </a:p>
           <a:p>
@@ -1860,7 +1902,7 @@
                 </a:solidFill>
                 <a:latin typeface="Calibri"/>
               </a:rPr>
-              <a:t>Huanuco: 5</a:t>
+              <a:t>Huanuco: 7</a:t>
             </a:r>
           </a:p>
           <a:p>
@@ -1890,21 +1932,6 @@
                 </a:solidFill>
                 <a:latin typeface="Calibri"/>
               </a:rPr>
-              <a:t>Huánuco: 2</a:t>
-            </a:r>
-          </a:p>
-          <a:p>
-            <a:pPr marL="0" indent="0">
-              <a:buFont typeface="Arial"/>
-              <a:buChar char="•"/>
-            </a:pPr>
-            <a:r>
-              <a:rPr lang="es-PE" sz="1200" dirty="0">
-                <a:solidFill>
-                  <a:srgbClr val="223344"/>
-                </a:solidFill>
-                <a:latin typeface="Calibri"/>
-              </a:rPr>
               <a:t>Dos De Mayo: 1</a:t>
             </a:r>
           </a:p>
@@ -1919,7 +1946,21 @@
                 </a:solidFill>
                 <a:latin typeface="Calibri"/>
               </a:rPr>
-              <a:t>Círculo = tipo I · cuadrado = tipo II. Ubicación aproximada al distrito declarado.</a:t>
+              <a:t>Sin bancos: Ambo, Huacaybamba, Huamalies, Lauricocha, Marañon, Pachitea, Puerto Inca, Yarowilca</a:t>
+            </a:r>
+          </a:p>
+          <a:p>
+            <a:pPr marL="0" indent="0">
+              <a:buNone/>
+            </a:pPr>
+            <a:r>
+              <a:rPr lang="es-PE" sz="900" dirty="0">
+                <a:solidFill>
+                  <a:srgbClr val="7A8699"/>
+                </a:solidFill>
+                <a:latin typeface="Calibri"/>
+              </a:rPr>
+              <a:t>Círculo = tipo I · cuadrado = tipo II · el número es la cantidad de bancos en un mismo punto. Ubicación aproximada al distrito declarado.</a:t>
             </a:r>
           </a:p>
         </p:txBody>
@@ -1980,7 +2021,7 @@
                 </a:solidFill>
                 <a:latin typeface="Calibri"/>
               </a:rPr>
-              <a:t>Ica · ubicación de los bancos de sangre</a:t>
+              <a:t>Ica · provincias y ubicación de los bancos de sangre</a:t>
             </a:r>
           </a:p>
         </p:txBody>
@@ -2017,8 +2058,8 @@
         </p:nvSpPr>
         <p:spPr>
           <a:xfrm>
-            <a:off x="8100000" y="1000000"/>
-            <a:ext cx="3800000" cy="5700000"/>
+            <a:off x="8100000" y="950000"/>
+            <a:ext cx="3900000" cy="5800000"/>
           </a:xfrm>
           <a:prstGeom prst="rect">
             <a:avLst/>
@@ -2049,7 +2090,7 @@
               <a:buChar char="•"/>
             </a:pPr>
             <a:r>
-              <a:rPr lang="es-PE" sz="1700" dirty="0">
+              <a:rPr lang="es-PE" sz="1600" dirty="0">
                 <a:solidFill>
                   <a:srgbClr val="C2334D"/>
                 </a:solidFill>
@@ -2064,7 +2105,7 @@
               <a:buChar char="•"/>
             </a:pPr>
             <a:r>
-              <a:rPr lang="es-PE" sz="1700" dirty="0">
+              <a:rPr lang="es-PE" sz="1600" dirty="0">
                 <a:solidFill>
                   <a:srgbClr val="1F6F8B"/>
                 </a:solidFill>
@@ -2079,7 +2120,7 @@
               <a:buChar char="•"/>
             </a:pPr>
             <a:r>
-              <a:rPr lang="es-PE" sz="1700" dirty="0">
+              <a:rPr lang="es-PE" sz="1600" dirty="0">
                 <a:solidFill>
                   <a:srgbClr val="B7791F"/>
                 </a:solidFill>
@@ -2094,7 +2135,7 @@
               <a:buChar char="•"/>
             </a:pPr>
             <a:r>
-              <a:rPr lang="es-PE" sz="1700" dirty="0">
+              <a:rPr lang="es-PE" sz="1600" dirty="0">
                 <a:solidFill>
                   <a:srgbClr val="2F6B3F"/>
                 </a:solidFill>
@@ -2108,13 +2149,13 @@
               <a:buNone/>
             </a:pPr>
             <a:r>
-              <a:rPr lang="es-PE" sz="1400" b="1" dirty="0">
+              <a:rPr lang="es-PE" sz="1300" b="1" dirty="0">
                 <a:solidFill>
                   <a:srgbClr val="445066"/>
                 </a:solidFill>
                 <a:latin typeface="Calibri"/>
               </a:rPr>
-              <a:t>Principales provincias</a:t>
+              <a:t>Provincias: 5 (con banco: 3)</a:t>
             </a:r>
           </a:p>
           <a:p>
@@ -2144,7 +2185,7 @@
                 </a:solidFill>
                 <a:latin typeface="Calibri"/>
               </a:rPr>
-              <a:t>Chincha: 5</a:t>
+              <a:t>Chincha: 6</a:t>
             </a:r>
           </a:p>
           <a:p>
@@ -2159,21 +2200,6 @@
                 </a:solidFill>
                 <a:latin typeface="Calibri"/>
               </a:rPr>
-              <a:t>Chncha: 1</a:t>
-            </a:r>
-          </a:p>
-          <a:p>
-            <a:pPr marL="0" indent="0">
-              <a:buFont typeface="Arial"/>
-              <a:buChar char="•"/>
-            </a:pPr>
-            <a:r>
-              <a:rPr lang="es-PE" sz="1200" dirty="0">
-                <a:solidFill>
-                  <a:srgbClr val="223344"/>
-                </a:solidFill>
-                <a:latin typeface="Calibri"/>
-              </a:rPr>
               <a:t>Pisco: 1</a:t>
             </a:r>
           </a:p>
@@ -2188,7 +2214,21 @@
                 </a:solidFill>
                 <a:latin typeface="Calibri"/>
               </a:rPr>
-              <a:t>Círculo = tipo I · cuadrado = tipo II. Ubicación aproximada al distrito declarado.</a:t>
+              <a:t>Sin bancos: Nazca, Palpa</a:t>
+            </a:r>
+          </a:p>
+          <a:p>
+            <a:pPr marL="0" indent="0">
+              <a:buNone/>
+            </a:pPr>
+            <a:r>
+              <a:rPr lang="es-PE" sz="900" dirty="0">
+                <a:solidFill>
+                  <a:srgbClr val="7A8699"/>
+                </a:solidFill>
+                <a:latin typeface="Calibri"/>
+              </a:rPr>
+              <a:t>Círculo = tipo I · cuadrado = tipo II · el número es la cantidad de bancos en un mismo punto. Ubicación aproximada al distrito declarado.</a:t>
             </a:r>
           </a:p>
         </p:txBody>
@@ -2249,7 +2289,7 @@
                 </a:solidFill>
                 <a:latin typeface="Calibri"/>
               </a:rPr>
-              <a:t>Junín · ubicación de los bancos de sangre</a:t>
+              <a:t>Junín · provincias y ubicación de los bancos de sangre</a:t>
             </a:r>
           </a:p>
         </p:txBody>
@@ -2286,8 +2326,8 @@
         </p:nvSpPr>
         <p:spPr>
           <a:xfrm>
-            <a:off x="8100000" y="1000000"/>
-            <a:ext cx="3800000" cy="5700000"/>
+            <a:off x="8100000" y="950000"/>
+            <a:ext cx="3900000" cy="5800000"/>
           </a:xfrm>
           <a:prstGeom prst="rect">
             <a:avLst/>
@@ -2318,7 +2358,7 @@
               <a:buChar char="•"/>
             </a:pPr>
             <a:r>
-              <a:rPr lang="es-PE" sz="1700" dirty="0">
+              <a:rPr lang="es-PE" sz="1600" dirty="0">
                 <a:solidFill>
                   <a:srgbClr val="C2334D"/>
                 </a:solidFill>
@@ -2333,7 +2373,7 @@
               <a:buChar char="•"/>
             </a:pPr>
             <a:r>
-              <a:rPr lang="es-PE" sz="1700" dirty="0">
+              <a:rPr lang="es-PE" sz="1600" dirty="0">
                 <a:solidFill>
                   <a:srgbClr val="1F6F8B"/>
                 </a:solidFill>
@@ -2348,7 +2388,7 @@
               <a:buChar char="•"/>
             </a:pPr>
             <a:r>
-              <a:rPr lang="es-PE" sz="1700" dirty="0">
+              <a:rPr lang="es-PE" sz="1600" dirty="0">
                 <a:solidFill>
                   <a:srgbClr val="B7791F"/>
                 </a:solidFill>
@@ -2363,7 +2403,7 @@
               <a:buChar char="•"/>
             </a:pPr>
             <a:r>
-              <a:rPr lang="es-PE" sz="1700" dirty="0">
+              <a:rPr lang="es-PE" sz="1600" dirty="0">
                 <a:solidFill>
                   <a:srgbClr val="2F6B3F"/>
                 </a:solidFill>
@@ -2377,13 +2417,13 @@
               <a:buNone/>
             </a:pPr>
             <a:r>
-              <a:rPr lang="es-PE" sz="1400" b="1" dirty="0">
+              <a:rPr lang="es-PE" sz="1300" b="1" dirty="0">
                 <a:solidFill>
                   <a:srgbClr val="445066"/>
                 </a:solidFill>
                 <a:latin typeface="Calibri"/>
               </a:rPr>
-              <a:t>Principales provincias</a:t>
+              <a:t>Provincias: 9 (con banco: 7)</a:t>
             </a:r>
           </a:p>
           <a:p>
@@ -2443,7 +2483,7 @@
                 </a:solidFill>
                 <a:latin typeface="Calibri"/>
               </a:rPr>
-              <a:t>Concepción: 1</a:t>
+              <a:t>Concepcion: 1</a:t>
             </a:r>
           </a:p>
           <a:p>
@@ -2458,41 +2498,41 @@
                 </a:solidFill>
                 <a:latin typeface="Calibri"/>
               </a:rPr>
+              <a:t>Junin: 1</a:t>
+            </a:r>
+          </a:p>
+          <a:p>
+            <a:pPr marL="0" indent="0">
+              <a:buFont typeface="Arial"/>
+              <a:buChar char="•"/>
+            </a:pPr>
+            <a:r>
+              <a:rPr lang="es-PE" sz="1200" dirty="0">
+                <a:solidFill>
+                  <a:srgbClr val="223344"/>
+                </a:solidFill>
+                <a:latin typeface="Calibri"/>
+              </a:rPr>
+              <a:t>Satipo: 1</a:t>
+            </a:r>
+          </a:p>
+          <a:p>
+            <a:pPr marL="0" indent="0">
+              <a:buFont typeface="Arial"/>
+              <a:buChar char="•"/>
+            </a:pPr>
+            <a:r>
+              <a:rPr lang="es-PE" sz="1200" dirty="0">
+                <a:solidFill>
+                  <a:srgbClr val="223344"/>
+                </a:solidFill>
+                <a:latin typeface="Calibri"/>
+              </a:rPr>
               <a:t>Yauli: 1</a:t>
             </a:r>
           </a:p>
           <a:p>
             <a:pPr marL="0" indent="0">
-              <a:buFont typeface="Arial"/>
-              <a:buChar char="•"/>
-            </a:pPr>
-            <a:r>
-              <a:rPr lang="es-PE" sz="1200" dirty="0">
-                <a:solidFill>
-                  <a:srgbClr val="223344"/>
-                </a:solidFill>
-                <a:latin typeface="Calibri"/>
-              </a:rPr>
-              <a:t>Junin: 1</a:t>
-            </a:r>
-          </a:p>
-          <a:p>
-            <a:pPr marL="0" indent="0">
-              <a:buFont typeface="Arial"/>
-              <a:buChar char="•"/>
-            </a:pPr>
-            <a:r>
-              <a:rPr lang="es-PE" sz="1200" dirty="0">
-                <a:solidFill>
-                  <a:srgbClr val="223344"/>
-                </a:solidFill>
-                <a:latin typeface="Calibri"/>
-              </a:rPr>
-              <a:t>Satipo: 1</a:t>
-            </a:r>
-          </a:p>
-          <a:p>
-            <a:pPr marL="0" indent="0">
               <a:buNone/>
             </a:pPr>
             <a:r>
@@ -2502,7 +2542,21 @@
                 </a:solidFill>
                 <a:latin typeface="Calibri"/>
               </a:rPr>
-              <a:t>Círculo = tipo I · cuadrado = tipo II. Ubicación aproximada al distrito declarado.</a:t>
+              <a:t>Sin bancos: Chupaca, Tarma</a:t>
+            </a:r>
+          </a:p>
+          <a:p>
+            <a:pPr marL="0" indent="0">
+              <a:buNone/>
+            </a:pPr>
+            <a:r>
+              <a:rPr lang="es-PE" sz="900" dirty="0">
+                <a:solidFill>
+                  <a:srgbClr val="7A8699"/>
+                </a:solidFill>
+                <a:latin typeface="Calibri"/>
+              </a:rPr>
+              <a:t>Círculo = tipo I · cuadrado = tipo II · el número es la cantidad de bancos en un mismo punto. Ubicación aproximada al distrito declarado.</a:t>
             </a:r>
           </a:p>
         </p:txBody>
@@ -2563,7 +2617,7 @@
                 </a:solidFill>
                 <a:latin typeface="Calibri"/>
               </a:rPr>
-              <a:t>La Libertad · ubicación de los bancos de sangre</a:t>
+              <a:t>La Libertad · provincias y ubicación de los bancos de sangre</a:t>
             </a:r>
           </a:p>
         </p:txBody>
@@ -2600,8 +2654,8 @@
         </p:nvSpPr>
         <p:spPr>
           <a:xfrm>
-            <a:off x="8100000" y="1000000"/>
-            <a:ext cx="3800000" cy="5700000"/>
+            <a:off x="8100000" y="950000"/>
+            <a:ext cx="3900000" cy="5800000"/>
           </a:xfrm>
           <a:prstGeom prst="rect">
             <a:avLst/>
@@ -2632,7 +2686,7 @@
               <a:buChar char="•"/>
             </a:pPr>
             <a:r>
-              <a:rPr lang="es-PE" sz="1700" dirty="0">
+              <a:rPr lang="es-PE" sz="1600" dirty="0">
                 <a:solidFill>
                   <a:srgbClr val="C2334D"/>
                 </a:solidFill>
@@ -2647,7 +2701,7 @@
               <a:buChar char="•"/>
             </a:pPr>
             <a:r>
-              <a:rPr lang="es-PE" sz="1700" dirty="0">
+              <a:rPr lang="es-PE" sz="1600" dirty="0">
                 <a:solidFill>
                   <a:srgbClr val="1F6F8B"/>
                 </a:solidFill>
@@ -2662,7 +2716,7 @@
               <a:buChar char="•"/>
             </a:pPr>
             <a:r>
-              <a:rPr lang="es-PE" sz="1700" dirty="0">
+              <a:rPr lang="es-PE" sz="1600" dirty="0">
                 <a:solidFill>
                   <a:srgbClr val="B7791F"/>
                 </a:solidFill>
@@ -2677,7 +2731,7 @@
               <a:buChar char="•"/>
             </a:pPr>
             <a:r>
-              <a:rPr lang="es-PE" sz="1700" dirty="0">
+              <a:rPr lang="es-PE" sz="1600" dirty="0">
                 <a:solidFill>
                   <a:srgbClr val="2F6B3F"/>
                 </a:solidFill>
@@ -2691,13 +2745,13 @@
               <a:buNone/>
             </a:pPr>
             <a:r>
-              <a:rPr lang="es-PE" sz="1400" b="1" dirty="0">
+              <a:rPr lang="es-PE" sz="1300" b="1" dirty="0">
                 <a:solidFill>
                   <a:srgbClr val="445066"/>
                 </a:solidFill>
                 <a:latin typeface="Calibri"/>
               </a:rPr>
-              <a:t>Principales provincias</a:t>
+              <a:t>Provincias: 12 (con banco: 8)</a:t>
             </a:r>
           </a:p>
           <a:p>
@@ -2727,6 +2781,81 @@
                 </a:solidFill>
                 <a:latin typeface="Calibri"/>
               </a:rPr>
+              <a:t>Ascope: 1</a:t>
+            </a:r>
+          </a:p>
+          <a:p>
+            <a:pPr marL="0" indent="0">
+              <a:buFont typeface="Arial"/>
+              <a:buChar char="•"/>
+            </a:pPr>
+            <a:r>
+              <a:rPr lang="es-PE" sz="1200" dirty="0">
+                <a:solidFill>
+                  <a:srgbClr val="223344"/>
+                </a:solidFill>
+                <a:latin typeface="Calibri"/>
+              </a:rPr>
+              <a:t>Chepen: 1</a:t>
+            </a:r>
+          </a:p>
+          <a:p>
+            <a:pPr marL="0" indent="0">
+              <a:buFont typeface="Arial"/>
+              <a:buChar char="•"/>
+            </a:pPr>
+            <a:r>
+              <a:rPr lang="es-PE" sz="1200" dirty="0">
+                <a:solidFill>
+                  <a:srgbClr val="223344"/>
+                </a:solidFill>
+                <a:latin typeface="Calibri"/>
+              </a:rPr>
+              <a:t>Otuzco: 1</a:t>
+            </a:r>
+          </a:p>
+          <a:p>
+            <a:pPr marL="0" indent="0">
+              <a:buFont typeface="Arial"/>
+              <a:buChar char="•"/>
+            </a:pPr>
+            <a:r>
+              <a:rPr lang="es-PE" sz="1200" dirty="0">
+                <a:solidFill>
+                  <a:srgbClr val="223344"/>
+                </a:solidFill>
+                <a:latin typeface="Calibri"/>
+              </a:rPr>
+              <a:t>Pacasmayo: 1</a:t>
+            </a:r>
+          </a:p>
+          <a:p>
+            <a:pPr marL="0" indent="0">
+              <a:buFont typeface="Arial"/>
+              <a:buChar char="•"/>
+            </a:pPr>
+            <a:r>
+              <a:rPr lang="es-PE" sz="1200" dirty="0">
+                <a:solidFill>
+                  <a:srgbClr val="223344"/>
+                </a:solidFill>
+                <a:latin typeface="Calibri"/>
+              </a:rPr>
+              <a:t>Sanchez Carrion: 1</a:t>
+            </a:r>
+          </a:p>
+          <a:p>
+            <a:pPr marL="0" indent="0">
+              <a:buFont typeface="Arial"/>
+              <a:buChar char="•"/>
+            </a:pPr>
+            <a:r>
+              <a:rPr lang="es-PE" sz="1200" dirty="0">
+                <a:solidFill>
+                  <a:srgbClr val="223344"/>
+                </a:solidFill>
+                <a:latin typeface="Calibri"/>
+              </a:rPr>
               <a:t>Santiago De Chuco: 1</a:t>
             </a:r>
           </a:p>
@@ -2742,86 +2871,11 @@
                 </a:solidFill>
                 <a:latin typeface="Calibri"/>
               </a:rPr>
-              <a:t>Pacasmayo: 1</a:t>
-            </a:r>
-          </a:p>
-          <a:p>
-            <a:pPr marL="0" indent="0">
-              <a:buFont typeface="Arial"/>
-              <a:buChar char="•"/>
-            </a:pPr>
-            <a:r>
-              <a:rPr lang="es-PE" sz="1200" dirty="0">
-                <a:solidFill>
-                  <a:srgbClr val="223344"/>
-                </a:solidFill>
-                <a:latin typeface="Calibri"/>
-              </a:rPr>
-              <a:t>Chepen: 1</a:t>
-            </a:r>
-          </a:p>
-          <a:p>
-            <a:pPr marL="0" indent="0">
-              <a:buFont typeface="Arial"/>
-              <a:buChar char="•"/>
-            </a:pPr>
-            <a:r>
-              <a:rPr lang="es-PE" sz="1200" dirty="0">
-                <a:solidFill>
-                  <a:srgbClr val="223344"/>
-                </a:solidFill>
-                <a:latin typeface="Calibri"/>
-              </a:rPr>
               <a:t>Viru: 1</a:t>
             </a:r>
           </a:p>
           <a:p>
             <a:pPr marL="0" indent="0">
-              <a:buFont typeface="Arial"/>
-              <a:buChar char="•"/>
-            </a:pPr>
-            <a:r>
-              <a:rPr lang="es-PE" sz="1200" dirty="0">
-                <a:solidFill>
-                  <a:srgbClr val="223344"/>
-                </a:solidFill>
-                <a:latin typeface="Calibri"/>
-              </a:rPr>
-              <a:t>Sanchez Carrion: 1</a:t>
-            </a:r>
-          </a:p>
-          <a:p>
-            <a:pPr marL="0" indent="0">
-              <a:buFont typeface="Arial"/>
-              <a:buChar char="•"/>
-            </a:pPr>
-            <a:r>
-              <a:rPr lang="es-PE" sz="1200" dirty="0">
-                <a:solidFill>
-                  <a:srgbClr val="223344"/>
-                </a:solidFill>
-                <a:latin typeface="Calibri"/>
-              </a:rPr>
-              <a:t>Otuzco: 1</a:t>
-            </a:r>
-          </a:p>
-          <a:p>
-            <a:pPr marL="0" indent="0">
-              <a:buFont typeface="Arial"/>
-              <a:buChar char="•"/>
-            </a:pPr>
-            <a:r>
-              <a:rPr lang="es-PE" sz="1200" dirty="0">
-                <a:solidFill>
-                  <a:srgbClr val="223344"/>
-                </a:solidFill>
-                <a:latin typeface="Calibri"/>
-              </a:rPr>
-              <a:t>Ascope: 1</a:t>
-            </a:r>
-          </a:p>
-          <a:p>
-            <a:pPr marL="0" indent="0">
               <a:buNone/>
             </a:pPr>
             <a:r>
@@ -2831,7 +2885,21 @@
                 </a:solidFill>
                 <a:latin typeface="Calibri"/>
               </a:rPr>
-              <a:t>Círculo = tipo I · cuadrado = tipo II. Ubicación aproximada al distrito declarado.</a:t>
+              <a:t>Sin bancos: Bolivar, Gran Chimu, Julcan, Pataz</a:t>
+            </a:r>
+          </a:p>
+          <a:p>
+            <a:pPr marL="0" indent="0">
+              <a:buNone/>
+            </a:pPr>
+            <a:r>
+              <a:rPr lang="es-PE" sz="900" dirty="0">
+                <a:solidFill>
+                  <a:srgbClr val="7A8699"/>
+                </a:solidFill>
+                <a:latin typeface="Calibri"/>
+              </a:rPr>
+              <a:t>Círculo = tipo I · cuadrado = tipo II · el número es la cantidad de bancos en un mismo punto. Ubicación aproximada al distrito declarado.</a:t>
             </a:r>
           </a:p>
         </p:txBody>
@@ -2892,7 +2960,7 @@
                 </a:solidFill>
                 <a:latin typeface="Calibri"/>
               </a:rPr>
-              <a:t>Lambayeque · ubicación de los bancos de sangre</a:t>
+              <a:t>Lambayeque · provincias y ubicación de los bancos de sangre</a:t>
             </a:r>
           </a:p>
         </p:txBody>
@@ -2929,8 +2997,8 @@
         </p:nvSpPr>
         <p:spPr>
           <a:xfrm>
-            <a:off x="8100000" y="1000000"/>
-            <a:ext cx="3800000" cy="5700000"/>
+            <a:off x="8100000" y="950000"/>
+            <a:ext cx="3900000" cy="5800000"/>
           </a:xfrm>
           <a:prstGeom prst="rect">
             <a:avLst/>
@@ -2961,7 +3029,7 @@
               <a:buChar char="•"/>
             </a:pPr>
             <a:r>
-              <a:rPr lang="es-PE" sz="1700" dirty="0">
+              <a:rPr lang="es-PE" sz="1600" dirty="0">
                 <a:solidFill>
                   <a:srgbClr val="C2334D"/>
                 </a:solidFill>
@@ -2976,7 +3044,7 @@
               <a:buChar char="•"/>
             </a:pPr>
             <a:r>
-              <a:rPr lang="es-PE" sz="1700" dirty="0">
+              <a:rPr lang="es-PE" sz="1600" dirty="0">
                 <a:solidFill>
                   <a:srgbClr val="1F6F8B"/>
                 </a:solidFill>
@@ -2991,7 +3059,7 @@
               <a:buChar char="•"/>
             </a:pPr>
             <a:r>
-              <a:rPr lang="es-PE" sz="1700" dirty="0">
+              <a:rPr lang="es-PE" sz="1600" dirty="0">
                 <a:solidFill>
                   <a:srgbClr val="B7791F"/>
                 </a:solidFill>
@@ -3006,7 +3074,7 @@
               <a:buChar char="•"/>
             </a:pPr>
             <a:r>
-              <a:rPr lang="es-PE" sz="1700" dirty="0">
+              <a:rPr lang="es-PE" sz="1600" dirty="0">
                 <a:solidFill>
                   <a:srgbClr val="2F6B3F"/>
                 </a:solidFill>
@@ -3020,13 +3088,13 @@
               <a:buNone/>
             </a:pPr>
             <a:r>
-              <a:rPr lang="es-PE" sz="1400" b="1" dirty="0">
+              <a:rPr lang="es-PE" sz="1300" b="1" dirty="0">
                 <a:solidFill>
                   <a:srgbClr val="445066"/>
                 </a:solidFill>
                 <a:latin typeface="Calibri"/>
               </a:rPr>
-              <a:t>Principales provincias</a:t>
+              <a:t>Provincias: 3 (con banco: 2)</a:t>
             </a:r>
           </a:p>
           <a:p>
@@ -3070,7 +3138,21 @@
                 </a:solidFill>
                 <a:latin typeface="Calibri"/>
               </a:rPr>
-              <a:t>Círculo = tipo I · cuadrado = tipo II. Ubicación aproximada al distrito declarado.</a:t>
+              <a:t>Sin bancos: Ferreñafe</a:t>
+            </a:r>
+          </a:p>
+          <a:p>
+            <a:pPr marL="0" indent="0">
+              <a:buNone/>
+            </a:pPr>
+            <a:r>
+              <a:rPr lang="es-PE" sz="900" dirty="0">
+                <a:solidFill>
+                  <a:srgbClr val="7A8699"/>
+                </a:solidFill>
+                <a:latin typeface="Calibri"/>
+              </a:rPr>
+              <a:t>Círculo = tipo I · cuadrado = tipo II · el número es la cantidad de bancos en un mismo punto. Ubicación aproximada al distrito declarado.</a:t>
             </a:r>
           </a:p>
         </p:txBody>
@@ -3131,7 +3213,7 @@
                 </a:solidFill>
                 <a:latin typeface="Calibri"/>
               </a:rPr>
-              <a:t>Lima · ubicación de los bancos de sangre</a:t>
+              <a:t>Lima · provincias y ubicación de los bancos de sangre</a:t>
             </a:r>
           </a:p>
         </p:txBody>
@@ -3168,8 +3250,8 @@
         </p:nvSpPr>
         <p:spPr>
           <a:xfrm>
-            <a:off x="8100000" y="1000000"/>
-            <a:ext cx="3800000" cy="5700000"/>
+            <a:off x="8100000" y="950000"/>
+            <a:ext cx="3900000" cy="5800000"/>
           </a:xfrm>
           <a:prstGeom prst="rect">
             <a:avLst/>
@@ -3200,7 +3282,7 @@
               <a:buChar char="•"/>
             </a:pPr>
             <a:r>
-              <a:rPr lang="es-PE" sz="1700" dirty="0">
+              <a:rPr lang="es-PE" sz="1600" dirty="0">
                 <a:solidFill>
                   <a:srgbClr val="C2334D"/>
                 </a:solidFill>
@@ -3215,7 +3297,7 @@
               <a:buChar char="•"/>
             </a:pPr>
             <a:r>
-              <a:rPr lang="es-PE" sz="1700" dirty="0">
+              <a:rPr lang="es-PE" sz="1600" dirty="0">
                 <a:solidFill>
                   <a:srgbClr val="1F6F8B"/>
                 </a:solidFill>
@@ -3230,7 +3312,7 @@
               <a:buChar char="•"/>
             </a:pPr>
             <a:r>
-              <a:rPr lang="es-PE" sz="1700" dirty="0">
+              <a:rPr lang="es-PE" sz="1600" dirty="0">
                 <a:solidFill>
                   <a:srgbClr val="B7791F"/>
                 </a:solidFill>
@@ -3245,7 +3327,7 @@
               <a:buChar char="•"/>
             </a:pPr>
             <a:r>
-              <a:rPr lang="es-PE" sz="1700" dirty="0">
+              <a:rPr lang="es-PE" sz="1600" dirty="0">
                 <a:solidFill>
                   <a:srgbClr val="2F6B3F"/>
                 </a:solidFill>
@@ -3259,13 +3341,13 @@
               <a:buNone/>
             </a:pPr>
             <a:r>
-              <a:rPr lang="es-PE" sz="1400" b="1" dirty="0">
+              <a:rPr lang="es-PE" sz="1300" b="1" dirty="0">
                 <a:solidFill>
                   <a:srgbClr val="445066"/>
                 </a:solidFill>
                 <a:latin typeface="Calibri"/>
               </a:rPr>
-              <a:t>Principales provincias</a:t>
+              <a:t>Provincias: 10 (con banco: 6)</a:t>
             </a:r>
           </a:p>
           <a:p>
@@ -3325,6 +3407,21 @@
                 </a:solidFill>
                 <a:latin typeface="Calibri"/>
               </a:rPr>
+              <a:t>Barranca: 1</a:t>
+            </a:r>
+          </a:p>
+          <a:p>
+            <a:pPr marL="0" indent="0">
+              <a:buFont typeface="Arial"/>
+              <a:buChar char="•"/>
+            </a:pPr>
+            <a:r>
+              <a:rPr lang="es-PE" sz="1200" dirty="0">
+                <a:solidFill>
+                  <a:srgbClr val="223344"/>
+                </a:solidFill>
+                <a:latin typeface="Calibri"/>
+              </a:rPr>
               <a:t>Huaral: 1</a:t>
             </a:r>
           </a:p>
@@ -3340,21 +3437,6 @@
                 </a:solidFill>
                 <a:latin typeface="Calibri"/>
               </a:rPr>
-              <a:t>Barranca: 1</a:t>
-            </a:r>
-          </a:p>
-          <a:p>
-            <a:pPr marL="0" indent="0">
-              <a:buFont typeface="Arial"/>
-              <a:buChar char="•"/>
-            </a:pPr>
-            <a:r>
-              <a:rPr lang="es-PE" sz="1200" dirty="0">
-                <a:solidFill>
-                  <a:srgbClr val="223344"/>
-                </a:solidFill>
-                <a:latin typeface="Calibri"/>
-              </a:rPr>
               <a:t>Huarochiri: 1</a:t>
             </a:r>
           </a:p>
@@ -3369,7 +3451,21 @@
                 </a:solidFill>
                 <a:latin typeface="Calibri"/>
               </a:rPr>
-              <a:t>Círculo = tipo I · cuadrado = tipo II. Ubicación aproximada al distrito declarado.</a:t>
+              <a:t>Sin bancos: Cajatambo, Canta, Oyon, Yauyos</a:t>
+            </a:r>
+          </a:p>
+          <a:p>
+            <a:pPr marL="0" indent="0">
+              <a:buNone/>
+            </a:pPr>
+            <a:r>
+              <a:rPr lang="es-PE" sz="900" dirty="0">
+                <a:solidFill>
+                  <a:srgbClr val="7A8699"/>
+                </a:solidFill>
+                <a:latin typeface="Calibri"/>
+              </a:rPr>
+              <a:t>Círculo = tipo I · cuadrado = tipo II · el número es la cantidad de bancos en un mismo punto. Ubicación aproximada al distrito declarado.</a:t>
             </a:r>
           </a:p>
         </p:txBody>
@@ -3639,7 +3735,7 @@
                 </a:solidFill>
                 <a:latin typeface="Calibri"/>
               </a:rPr>
-              <a:t>Loreto · ubicación de los bancos de sangre</a:t>
+              <a:t>Loreto · provincias y ubicación de los bancos de sangre</a:t>
             </a:r>
           </a:p>
         </p:txBody>
@@ -3676,8 +3772,8 @@
         </p:nvSpPr>
         <p:spPr>
           <a:xfrm>
-            <a:off x="8100000" y="1000000"/>
-            <a:ext cx="3800000" cy="5700000"/>
+            <a:off x="8100000" y="950000"/>
+            <a:ext cx="3900000" cy="5800000"/>
           </a:xfrm>
           <a:prstGeom prst="rect">
             <a:avLst/>
@@ -3708,7 +3804,7 @@
               <a:buChar char="•"/>
             </a:pPr>
             <a:r>
-              <a:rPr lang="es-PE" sz="1700" dirty="0">
+              <a:rPr lang="es-PE" sz="1600" dirty="0">
                 <a:solidFill>
                   <a:srgbClr val="C2334D"/>
                 </a:solidFill>
@@ -3723,7 +3819,7 @@
               <a:buChar char="•"/>
             </a:pPr>
             <a:r>
-              <a:rPr lang="es-PE" sz="1700" dirty="0">
+              <a:rPr lang="es-PE" sz="1600" dirty="0">
                 <a:solidFill>
                   <a:srgbClr val="1F6F8B"/>
                 </a:solidFill>
@@ -3738,7 +3834,7 @@
               <a:buChar char="•"/>
             </a:pPr>
             <a:r>
-              <a:rPr lang="es-PE" sz="1700" dirty="0">
+              <a:rPr lang="es-PE" sz="1600" dirty="0">
                 <a:solidFill>
                   <a:srgbClr val="B7791F"/>
                 </a:solidFill>
@@ -3753,7 +3849,7 @@
               <a:buChar char="•"/>
             </a:pPr>
             <a:r>
-              <a:rPr lang="es-PE" sz="1700" dirty="0">
+              <a:rPr lang="es-PE" sz="1600" dirty="0">
                 <a:solidFill>
                   <a:srgbClr val="2F6B3F"/>
                 </a:solidFill>
@@ -3767,13 +3863,13 @@
               <a:buNone/>
             </a:pPr>
             <a:r>
-              <a:rPr lang="es-PE" sz="1400" b="1" dirty="0">
+              <a:rPr lang="es-PE" sz="1300" b="1" dirty="0">
                 <a:solidFill>
                   <a:srgbClr val="445066"/>
                 </a:solidFill>
                 <a:latin typeface="Calibri"/>
               </a:rPr>
-              <a:t>Principales provincias</a:t>
+              <a:t>Provincias: 7 (con banco: 2)</a:t>
             </a:r>
           </a:p>
           <a:p>
@@ -3817,7 +3913,21 @@
                 </a:solidFill>
                 <a:latin typeface="Calibri"/>
               </a:rPr>
-              <a:t>Círculo = tipo I · cuadrado = tipo II. Ubicación aproximada al distrito declarado.</a:t>
+              <a:t>Sin bancos: Datem Del Marañon, Loreto, Mariscal Ramon Castilla, Requena, Ucayali</a:t>
+            </a:r>
+          </a:p>
+          <a:p>
+            <a:pPr marL="0" indent="0">
+              <a:buNone/>
+            </a:pPr>
+            <a:r>
+              <a:rPr lang="es-PE" sz="900" dirty="0">
+                <a:solidFill>
+                  <a:srgbClr val="7A8699"/>
+                </a:solidFill>
+                <a:latin typeface="Calibri"/>
+              </a:rPr>
+              <a:t>Círculo = tipo I · cuadrado = tipo II · el número es la cantidad de bancos en un mismo punto. Ubicación aproximada al distrito declarado.</a:t>
             </a:r>
           </a:p>
         </p:txBody>
@@ -3878,7 +3988,7 @@
                 </a:solidFill>
                 <a:latin typeface="Calibri"/>
               </a:rPr>
-              <a:t>Madre de Dios · ubicación de los bancos de sangre</a:t>
+              <a:t>Madre de Dios · provincias y ubicación de los bancos de sangre</a:t>
             </a:r>
           </a:p>
         </p:txBody>
@@ -3915,8 +4025,8 @@
         </p:nvSpPr>
         <p:spPr>
           <a:xfrm>
-            <a:off x="8100000" y="1000000"/>
-            <a:ext cx="3800000" cy="5700000"/>
+            <a:off x="8100000" y="950000"/>
+            <a:ext cx="3900000" cy="5800000"/>
           </a:xfrm>
           <a:prstGeom prst="rect">
             <a:avLst/>
@@ -3947,7 +4057,7 @@
               <a:buChar char="•"/>
             </a:pPr>
             <a:r>
-              <a:rPr lang="es-PE" sz="1700" dirty="0">
+              <a:rPr lang="es-PE" sz="1600" dirty="0">
                 <a:solidFill>
                   <a:srgbClr val="C2334D"/>
                 </a:solidFill>
@@ -3962,7 +4072,7 @@
               <a:buChar char="•"/>
             </a:pPr>
             <a:r>
-              <a:rPr lang="es-PE" sz="1700" dirty="0">
+              <a:rPr lang="es-PE" sz="1600" dirty="0">
                 <a:solidFill>
                   <a:srgbClr val="1F6F8B"/>
                 </a:solidFill>
@@ -3977,7 +4087,7 @@
               <a:buChar char="•"/>
             </a:pPr>
             <a:r>
-              <a:rPr lang="es-PE" sz="1700" dirty="0">
+              <a:rPr lang="es-PE" sz="1600" dirty="0">
                 <a:solidFill>
                   <a:srgbClr val="B7791F"/>
                 </a:solidFill>
@@ -3992,7 +4102,7 @@
               <a:buChar char="•"/>
             </a:pPr>
             <a:r>
-              <a:rPr lang="es-PE" sz="1700" dirty="0">
+              <a:rPr lang="es-PE" sz="1600" dirty="0">
                 <a:solidFill>
                   <a:srgbClr val="2F6B3F"/>
                 </a:solidFill>
@@ -4006,13 +4116,13 @@
               <a:buNone/>
             </a:pPr>
             <a:r>
-              <a:rPr lang="es-PE" sz="1400" b="1" dirty="0">
+              <a:rPr lang="es-PE" sz="1300" b="1" dirty="0">
                 <a:solidFill>
                   <a:srgbClr val="445066"/>
                 </a:solidFill>
                 <a:latin typeface="Calibri"/>
               </a:rPr>
-              <a:t>Principales provincias</a:t>
+              <a:t>Provincias: 3 (con banco: 1)</a:t>
             </a:r>
           </a:p>
           <a:p>
@@ -4041,7 +4151,21 @@
                 </a:solidFill>
                 <a:latin typeface="Calibri"/>
               </a:rPr>
-              <a:t>Círculo = tipo I · cuadrado = tipo II. Ubicación aproximada al distrito declarado.</a:t>
+              <a:t>Sin bancos: Manu, Tahuamanu</a:t>
+            </a:r>
+          </a:p>
+          <a:p>
+            <a:pPr marL="0" indent="0">
+              <a:buNone/>
+            </a:pPr>
+            <a:r>
+              <a:rPr lang="es-PE" sz="900" dirty="0">
+                <a:solidFill>
+                  <a:srgbClr val="7A8699"/>
+                </a:solidFill>
+                <a:latin typeface="Calibri"/>
+              </a:rPr>
+              <a:t>Círculo = tipo I · cuadrado = tipo II · el número es la cantidad de bancos en un mismo punto. Ubicación aproximada al distrito declarado.</a:t>
             </a:r>
           </a:p>
         </p:txBody>
@@ -4102,7 +4226,7 @@
                 </a:solidFill>
                 <a:latin typeface="Calibri"/>
               </a:rPr>
-              <a:t>Moquegua · ubicación de los bancos de sangre</a:t>
+              <a:t>Moquegua · provincias y ubicación de los bancos de sangre</a:t>
             </a:r>
           </a:p>
         </p:txBody>
@@ -4139,8 +4263,8 @@
         </p:nvSpPr>
         <p:spPr>
           <a:xfrm>
-            <a:off x="8100000" y="1000000"/>
-            <a:ext cx="3800000" cy="5700000"/>
+            <a:off x="8100000" y="950000"/>
+            <a:ext cx="3900000" cy="5800000"/>
           </a:xfrm>
           <a:prstGeom prst="rect">
             <a:avLst/>
@@ -4171,7 +4295,7 @@
               <a:buChar char="•"/>
             </a:pPr>
             <a:r>
-              <a:rPr lang="es-PE" sz="1700" dirty="0">
+              <a:rPr lang="es-PE" sz="1600" dirty="0">
                 <a:solidFill>
                   <a:srgbClr val="C2334D"/>
                 </a:solidFill>
@@ -4186,7 +4310,7 @@
               <a:buChar char="•"/>
             </a:pPr>
             <a:r>
-              <a:rPr lang="es-PE" sz="1700" dirty="0">
+              <a:rPr lang="es-PE" sz="1600" dirty="0">
                 <a:solidFill>
                   <a:srgbClr val="1F6F8B"/>
                 </a:solidFill>
@@ -4201,7 +4325,7 @@
               <a:buChar char="•"/>
             </a:pPr>
             <a:r>
-              <a:rPr lang="es-PE" sz="1700" dirty="0">
+              <a:rPr lang="es-PE" sz="1600" dirty="0">
                 <a:solidFill>
                   <a:srgbClr val="B7791F"/>
                 </a:solidFill>
@@ -4216,7 +4340,7 @@
               <a:buChar char="•"/>
             </a:pPr>
             <a:r>
-              <a:rPr lang="es-PE" sz="1700" dirty="0">
+              <a:rPr lang="es-PE" sz="1600" dirty="0">
                 <a:solidFill>
                   <a:srgbClr val="2F6B3F"/>
                 </a:solidFill>
@@ -4230,13 +4354,13 @@
               <a:buNone/>
             </a:pPr>
             <a:r>
-              <a:rPr lang="es-PE" sz="1400" b="1" dirty="0">
+              <a:rPr lang="es-PE" sz="1300" b="1" dirty="0">
                 <a:solidFill>
                   <a:srgbClr val="445066"/>
                 </a:solidFill>
                 <a:latin typeface="Calibri"/>
               </a:rPr>
-              <a:t>Principales provincias</a:t>
+              <a:t>Provincias: 3 (con banco: 2)</a:t>
             </a:r>
           </a:p>
           <a:p>
@@ -4280,7 +4404,21 @@
                 </a:solidFill>
                 <a:latin typeface="Calibri"/>
               </a:rPr>
-              <a:t>Círculo = tipo I · cuadrado = tipo II. Ubicación aproximada al distrito declarado.</a:t>
+              <a:t>Sin bancos: General Sanchez Cerro</a:t>
+            </a:r>
+          </a:p>
+          <a:p>
+            <a:pPr marL="0" indent="0">
+              <a:buNone/>
+            </a:pPr>
+            <a:r>
+              <a:rPr lang="es-PE" sz="900" dirty="0">
+                <a:solidFill>
+                  <a:srgbClr val="7A8699"/>
+                </a:solidFill>
+                <a:latin typeface="Calibri"/>
+              </a:rPr>
+              <a:t>Círculo = tipo I · cuadrado = tipo II · el número es la cantidad de bancos en un mismo punto. Ubicación aproximada al distrito declarado.</a:t>
             </a:r>
           </a:p>
         </p:txBody>
@@ -4341,7 +4479,7 @@
                 </a:solidFill>
                 <a:latin typeface="Calibri"/>
               </a:rPr>
-              <a:t>Pasco · ubicación de los bancos de sangre</a:t>
+              <a:t>Pasco · provincias y ubicación de los bancos de sangre</a:t>
             </a:r>
           </a:p>
         </p:txBody>
@@ -4378,8 +4516,8 @@
         </p:nvSpPr>
         <p:spPr>
           <a:xfrm>
-            <a:off x="8100000" y="1000000"/>
-            <a:ext cx="3800000" cy="5700000"/>
+            <a:off x="8100000" y="950000"/>
+            <a:ext cx="3900000" cy="5800000"/>
           </a:xfrm>
           <a:prstGeom prst="rect">
             <a:avLst/>
@@ -4410,7 +4548,7 @@
               <a:buChar char="•"/>
             </a:pPr>
             <a:r>
-              <a:rPr lang="es-PE" sz="1700" dirty="0">
+              <a:rPr lang="es-PE" sz="1600" dirty="0">
                 <a:solidFill>
                   <a:srgbClr val="C2334D"/>
                 </a:solidFill>
@@ -4425,7 +4563,7 @@
               <a:buChar char="•"/>
             </a:pPr>
             <a:r>
-              <a:rPr lang="es-PE" sz="1700" dirty="0">
+              <a:rPr lang="es-PE" sz="1600" dirty="0">
                 <a:solidFill>
                   <a:srgbClr val="1F6F8B"/>
                 </a:solidFill>
@@ -4440,7 +4578,7 @@
               <a:buChar char="•"/>
             </a:pPr>
             <a:r>
-              <a:rPr lang="es-PE" sz="1700" dirty="0">
+              <a:rPr lang="es-PE" sz="1600" dirty="0">
                 <a:solidFill>
                   <a:srgbClr val="B7791F"/>
                 </a:solidFill>
@@ -4455,7 +4593,7 @@
               <a:buChar char="•"/>
             </a:pPr>
             <a:r>
-              <a:rPr lang="es-PE" sz="1700" dirty="0">
+              <a:rPr lang="es-PE" sz="1600" dirty="0">
                 <a:solidFill>
                   <a:srgbClr val="2F6B3F"/>
                 </a:solidFill>
@@ -4469,13 +4607,13 @@
               <a:buNone/>
             </a:pPr>
             <a:r>
-              <a:rPr lang="es-PE" sz="1400" b="1" dirty="0">
+              <a:rPr lang="es-PE" sz="1300" b="1" dirty="0">
                 <a:solidFill>
                   <a:srgbClr val="445066"/>
                 </a:solidFill>
                 <a:latin typeface="Calibri"/>
               </a:rPr>
-              <a:t>Principales provincias</a:t>
+              <a:t>Provincias: 3 (con banco: 2)</a:t>
             </a:r>
           </a:p>
           <a:p>
@@ -4519,7 +4657,21 @@
                 </a:solidFill>
                 <a:latin typeface="Calibri"/>
               </a:rPr>
-              <a:t>Círculo = tipo I · cuadrado = tipo II. Ubicación aproximada al distrito declarado.</a:t>
+              <a:t>Sin bancos: Daniel Alcides Carrion</a:t>
+            </a:r>
+          </a:p>
+          <a:p>
+            <a:pPr marL="0" indent="0">
+              <a:buNone/>
+            </a:pPr>
+            <a:r>
+              <a:rPr lang="es-PE" sz="900" dirty="0">
+                <a:solidFill>
+                  <a:srgbClr val="7A8699"/>
+                </a:solidFill>
+                <a:latin typeface="Calibri"/>
+              </a:rPr>
+              <a:t>Círculo = tipo I · cuadrado = tipo II · el número es la cantidad de bancos en un mismo punto. Ubicación aproximada al distrito declarado.</a:t>
             </a:r>
           </a:p>
         </p:txBody>
@@ -4580,7 +4732,7 @@
                 </a:solidFill>
                 <a:latin typeface="Calibri"/>
               </a:rPr>
-              <a:t>Piura · ubicación de los bancos de sangre</a:t>
+              <a:t>Piura · provincias y ubicación de los bancos de sangre</a:t>
             </a:r>
           </a:p>
         </p:txBody>
@@ -4617,8 +4769,8 @@
         </p:nvSpPr>
         <p:spPr>
           <a:xfrm>
-            <a:off x="8100000" y="1000000"/>
-            <a:ext cx="3800000" cy="5700000"/>
+            <a:off x="8100000" y="950000"/>
+            <a:ext cx="3900000" cy="5800000"/>
           </a:xfrm>
           <a:prstGeom prst="rect">
             <a:avLst/>
@@ -4649,7 +4801,7 @@
               <a:buChar char="•"/>
             </a:pPr>
             <a:r>
-              <a:rPr lang="es-PE" sz="1700" dirty="0">
+              <a:rPr lang="es-PE" sz="1600" dirty="0">
                 <a:solidFill>
                   <a:srgbClr val="C2334D"/>
                 </a:solidFill>
@@ -4664,7 +4816,7 @@
               <a:buChar char="•"/>
             </a:pPr>
             <a:r>
-              <a:rPr lang="es-PE" sz="1700" dirty="0">
+              <a:rPr lang="es-PE" sz="1600" dirty="0">
                 <a:solidFill>
                   <a:srgbClr val="1F6F8B"/>
                 </a:solidFill>
@@ -4679,7 +4831,7 @@
               <a:buChar char="•"/>
             </a:pPr>
             <a:r>
-              <a:rPr lang="es-PE" sz="1700" dirty="0">
+              <a:rPr lang="es-PE" sz="1600" dirty="0">
                 <a:solidFill>
                   <a:srgbClr val="B7791F"/>
                 </a:solidFill>
@@ -4694,7 +4846,7 @@
               <a:buChar char="•"/>
             </a:pPr>
             <a:r>
-              <a:rPr lang="es-PE" sz="1700" dirty="0">
+              <a:rPr lang="es-PE" sz="1600" dirty="0">
                 <a:solidFill>
                   <a:srgbClr val="2F6B3F"/>
                 </a:solidFill>
@@ -4708,13 +4860,13 @@
               <a:buNone/>
             </a:pPr>
             <a:r>
-              <a:rPr lang="es-PE" sz="1400" b="1" dirty="0">
+              <a:rPr lang="es-PE" sz="1300" b="1" dirty="0">
                 <a:solidFill>
                   <a:srgbClr val="445066"/>
                 </a:solidFill>
                 <a:latin typeface="Calibri"/>
               </a:rPr>
-              <a:t>Principales provincias</a:t>
+              <a:t>Provincias: 9 (con banco: 5)</a:t>
             </a:r>
           </a:p>
           <a:p>
@@ -4729,7 +4881,7 @@
                 </a:solidFill>
                 <a:latin typeface="Calibri"/>
               </a:rPr>
-              <a:t>Piura: 18</a:t>
+              <a:t>Piura: 17</a:t>
             </a:r>
           </a:p>
           <a:p>
@@ -4744,7 +4896,7 @@
                 </a:solidFill>
                 <a:latin typeface="Calibri"/>
               </a:rPr>
-              <a:t>Sullana: 6</a:t>
+              <a:t>Sullana: 7</a:t>
             </a:r>
           </a:p>
           <a:p>
@@ -4759,6 +4911,21 @@
                 </a:solidFill>
                 <a:latin typeface="Calibri"/>
               </a:rPr>
+              <a:t>Morropon: 2</a:t>
+            </a:r>
+          </a:p>
+          <a:p>
+            <a:pPr marL="0" indent="0">
+              <a:buFont typeface="Arial"/>
+              <a:buChar char="•"/>
+            </a:pPr>
+            <a:r>
+              <a:rPr lang="es-PE" sz="1200" dirty="0">
+                <a:solidFill>
+                  <a:srgbClr val="223344"/>
+                </a:solidFill>
+                <a:latin typeface="Calibri"/>
+              </a:rPr>
               <a:t>Talara: 2</a:t>
             </a:r>
           </a:p>
@@ -4774,21 +4941,6 @@
                 </a:solidFill>
                 <a:latin typeface="Calibri"/>
               </a:rPr>
-              <a:t>Morropon: 2</a:t>
-            </a:r>
-          </a:p>
-          <a:p>
-            <a:pPr marL="0" indent="0">
-              <a:buFont typeface="Arial"/>
-              <a:buChar char="•"/>
-            </a:pPr>
-            <a:r>
-              <a:rPr lang="es-PE" sz="1200" dirty="0">
-                <a:solidFill>
-                  <a:srgbClr val="223344"/>
-                </a:solidFill>
-                <a:latin typeface="Calibri"/>
-              </a:rPr>
               <a:t>Paita: 1</a:t>
             </a:r>
           </a:p>
@@ -4803,7 +4955,21 @@
                 </a:solidFill>
                 <a:latin typeface="Calibri"/>
               </a:rPr>
-              <a:t>Círculo = tipo I · cuadrado = tipo II. Ubicación aproximada al distrito declarado.</a:t>
+              <a:t>Sin bancos: Ayabaca, Huancabamba, Puira, Sechura</a:t>
+            </a:r>
+          </a:p>
+          <a:p>
+            <a:pPr marL="0" indent="0">
+              <a:buNone/>
+            </a:pPr>
+            <a:r>
+              <a:rPr lang="es-PE" sz="900" dirty="0">
+                <a:solidFill>
+                  <a:srgbClr val="7A8699"/>
+                </a:solidFill>
+                <a:latin typeface="Calibri"/>
+              </a:rPr>
+              <a:t>Círculo = tipo I · cuadrado = tipo II · el número es la cantidad de bancos en un mismo punto. Ubicación aproximada al distrito declarado.</a:t>
             </a:r>
           </a:p>
         </p:txBody>
@@ -4864,7 +5030,7 @@
                 </a:solidFill>
                 <a:latin typeface="Calibri"/>
               </a:rPr>
-              <a:t>Puno · ubicación de los bancos de sangre</a:t>
+              <a:t>Puno · provincias y ubicación de los bancos de sangre</a:t>
             </a:r>
           </a:p>
         </p:txBody>
@@ -4901,8 +5067,8 @@
         </p:nvSpPr>
         <p:spPr>
           <a:xfrm>
-            <a:off x="8100000" y="1000000"/>
-            <a:ext cx="3800000" cy="5700000"/>
+            <a:off x="8100000" y="950000"/>
+            <a:ext cx="3900000" cy="5800000"/>
           </a:xfrm>
           <a:prstGeom prst="rect">
             <a:avLst/>
@@ -4933,7 +5099,7 @@
               <a:buChar char="•"/>
             </a:pPr>
             <a:r>
-              <a:rPr lang="es-PE" sz="1700" dirty="0">
+              <a:rPr lang="es-PE" sz="1600" dirty="0">
                 <a:solidFill>
                   <a:srgbClr val="C2334D"/>
                 </a:solidFill>
@@ -4948,7 +5114,7 @@
               <a:buChar char="•"/>
             </a:pPr>
             <a:r>
-              <a:rPr lang="es-PE" sz="1700" dirty="0">
+              <a:rPr lang="es-PE" sz="1600" dirty="0">
                 <a:solidFill>
                   <a:srgbClr val="1F6F8B"/>
                 </a:solidFill>
@@ -4963,7 +5129,7 @@
               <a:buChar char="•"/>
             </a:pPr>
             <a:r>
-              <a:rPr lang="es-PE" sz="1700" dirty="0">
+              <a:rPr lang="es-PE" sz="1600" dirty="0">
                 <a:solidFill>
                   <a:srgbClr val="B7791F"/>
                 </a:solidFill>
@@ -4978,7 +5144,7 @@
               <a:buChar char="•"/>
             </a:pPr>
             <a:r>
-              <a:rPr lang="es-PE" sz="1700" dirty="0">
+              <a:rPr lang="es-PE" sz="1600" dirty="0">
                 <a:solidFill>
                   <a:srgbClr val="2F6B3F"/>
                 </a:solidFill>
@@ -4992,13 +5158,13 @@
               <a:buNone/>
             </a:pPr>
             <a:r>
-              <a:rPr lang="es-PE" sz="1400" b="1" dirty="0">
+              <a:rPr lang="es-PE" sz="1300" b="1" dirty="0">
                 <a:solidFill>
                   <a:srgbClr val="445066"/>
                 </a:solidFill>
                 <a:latin typeface="Calibri"/>
               </a:rPr>
-              <a:t>Principales provincias</a:t>
+              <a:t>Provincias: 13 (con banco: 3)</a:t>
             </a:r>
           </a:p>
           <a:p>
@@ -5057,7 +5223,21 @@
                 </a:solidFill>
                 <a:latin typeface="Calibri"/>
               </a:rPr>
-              <a:t>Círculo = tipo I · cuadrado = tipo II. Ubicación aproximada al distrito declarado.</a:t>
+              <a:t>Sin bancos: Azangaro, Chucuito, El Collao, Huancane, Lampa, Melgar, Moho, San Antonio De Putina, Sandia, Yunguyo</a:t>
+            </a:r>
+          </a:p>
+          <a:p>
+            <a:pPr marL="0" indent="0">
+              <a:buNone/>
+            </a:pPr>
+            <a:r>
+              <a:rPr lang="es-PE" sz="900" dirty="0">
+                <a:solidFill>
+                  <a:srgbClr val="7A8699"/>
+                </a:solidFill>
+                <a:latin typeface="Calibri"/>
+              </a:rPr>
+              <a:t>Círculo = tipo I · cuadrado = tipo II · el número es la cantidad de bancos en un mismo punto. Ubicación aproximada al distrito declarado.</a:t>
             </a:r>
           </a:p>
         </p:txBody>
@@ -5118,7 +5298,7 @@
                 </a:solidFill>
                 <a:latin typeface="Calibri"/>
               </a:rPr>
-              <a:t>San Martín · ubicación de los bancos de sangre</a:t>
+              <a:t>San Martín · provincias y ubicación de los bancos de sangre</a:t>
             </a:r>
           </a:p>
         </p:txBody>
@@ -5155,8 +5335,8 @@
         </p:nvSpPr>
         <p:spPr>
           <a:xfrm>
-            <a:off x="8100000" y="1000000"/>
-            <a:ext cx="3800000" cy="5700000"/>
+            <a:off x="8100000" y="950000"/>
+            <a:ext cx="3900000" cy="5800000"/>
           </a:xfrm>
           <a:prstGeom prst="rect">
             <a:avLst/>
@@ -5187,7 +5367,7 @@
               <a:buChar char="•"/>
             </a:pPr>
             <a:r>
-              <a:rPr lang="es-PE" sz="1700" dirty="0">
+              <a:rPr lang="es-PE" sz="1600" dirty="0">
                 <a:solidFill>
                   <a:srgbClr val="C2334D"/>
                 </a:solidFill>
@@ -5202,7 +5382,7 @@
               <a:buChar char="•"/>
             </a:pPr>
             <a:r>
-              <a:rPr lang="es-PE" sz="1700" dirty="0">
+              <a:rPr lang="es-PE" sz="1600" dirty="0">
                 <a:solidFill>
                   <a:srgbClr val="1F6F8B"/>
                 </a:solidFill>
@@ -5217,7 +5397,7 @@
               <a:buChar char="•"/>
             </a:pPr>
             <a:r>
-              <a:rPr lang="es-PE" sz="1700" dirty="0">
+              <a:rPr lang="es-PE" sz="1600" dirty="0">
                 <a:solidFill>
                   <a:srgbClr val="B7791F"/>
                 </a:solidFill>
@@ -5232,7 +5412,7 @@
               <a:buChar char="•"/>
             </a:pPr>
             <a:r>
-              <a:rPr lang="es-PE" sz="1700" dirty="0">
+              <a:rPr lang="es-PE" sz="1600" dirty="0">
                 <a:solidFill>
                   <a:srgbClr val="2F6B3F"/>
                 </a:solidFill>
@@ -5246,13 +5426,13 @@
               <a:buNone/>
             </a:pPr>
             <a:r>
-              <a:rPr lang="es-PE" sz="1400" b="1" dirty="0">
+              <a:rPr lang="es-PE" sz="1300" b="1" dirty="0">
                 <a:solidFill>
                   <a:srgbClr val="445066"/>
                 </a:solidFill>
                 <a:latin typeface="Calibri"/>
               </a:rPr>
-              <a:t>Principales provincias</a:t>
+              <a:t>Provincias: 10 (con banco: 8)</a:t>
             </a:r>
           </a:p>
           <a:p>
@@ -5312,6 +5492,36 @@
                 </a:solidFill>
                 <a:latin typeface="Calibri"/>
               </a:rPr>
+              <a:t>Bellavista: 1</a:t>
+            </a:r>
+          </a:p>
+          <a:p>
+            <a:pPr marL="0" indent="0">
+              <a:buFont typeface="Arial"/>
+              <a:buChar char="•"/>
+            </a:pPr>
+            <a:r>
+              <a:rPr lang="es-PE" sz="1200" dirty="0">
+                <a:solidFill>
+                  <a:srgbClr val="223344"/>
+                </a:solidFill>
+                <a:latin typeface="Calibri"/>
+              </a:rPr>
+              <a:t>Huallaga: 1</a:t>
+            </a:r>
+          </a:p>
+          <a:p>
+            <a:pPr marL="0" indent="0">
+              <a:buFont typeface="Arial"/>
+              <a:buChar char="•"/>
+            </a:pPr>
+            <a:r>
+              <a:rPr lang="es-PE" sz="1200" dirty="0">
+                <a:solidFill>
+                  <a:srgbClr val="223344"/>
+                </a:solidFill>
+                <a:latin typeface="Calibri"/>
+              </a:rPr>
               <a:t>Mariscal Caceres: 1</a:t>
             </a:r>
           </a:p>
@@ -5327,56 +5537,26 @@
                 </a:solidFill>
                 <a:latin typeface="Calibri"/>
               </a:rPr>
+              <a:t>Picota: 1</a:t>
+            </a:r>
+          </a:p>
+          <a:p>
+            <a:pPr marL="0" indent="0">
+              <a:buFont typeface="Arial"/>
+              <a:buChar char="•"/>
+            </a:pPr>
+            <a:r>
+              <a:rPr lang="es-PE" sz="1200" dirty="0">
+                <a:solidFill>
+                  <a:srgbClr val="223344"/>
+                </a:solidFill>
+                <a:latin typeface="Calibri"/>
+              </a:rPr>
               <a:t>Tocache: 1</a:t>
             </a:r>
           </a:p>
           <a:p>
             <a:pPr marL="0" indent="0">
-              <a:buFont typeface="Arial"/>
-              <a:buChar char="•"/>
-            </a:pPr>
-            <a:r>
-              <a:rPr lang="es-PE" sz="1200" dirty="0">
-                <a:solidFill>
-                  <a:srgbClr val="223344"/>
-                </a:solidFill>
-                <a:latin typeface="Calibri"/>
-              </a:rPr>
-              <a:t>San Martín: 1</a:t>
-            </a:r>
-          </a:p>
-          <a:p>
-            <a:pPr marL="0" indent="0">
-              <a:buFont typeface="Arial"/>
-              <a:buChar char="•"/>
-            </a:pPr>
-            <a:r>
-              <a:rPr lang="es-PE" sz="1200" dirty="0">
-                <a:solidFill>
-                  <a:srgbClr val="223344"/>
-                </a:solidFill>
-                <a:latin typeface="Calibri"/>
-              </a:rPr>
-              <a:t>Bellavista: 1</a:t>
-            </a:r>
-          </a:p>
-          <a:p>
-            <a:pPr marL="0" indent="0">
-              <a:buFont typeface="Arial"/>
-              <a:buChar char="•"/>
-            </a:pPr>
-            <a:r>
-              <a:rPr lang="es-PE" sz="1200" dirty="0">
-                <a:solidFill>
-                  <a:srgbClr val="223344"/>
-                </a:solidFill>
-                <a:latin typeface="Calibri"/>
-              </a:rPr>
-              <a:t>Picota: 1</a:t>
-            </a:r>
-          </a:p>
-          <a:p>
-            <a:pPr marL="0" indent="0">
               <a:buNone/>
             </a:pPr>
             <a:r>
@@ -5386,7 +5566,21 @@
                 </a:solidFill>
                 <a:latin typeface="Calibri"/>
               </a:rPr>
-              <a:t>Círculo = tipo I · cuadrado = tipo II. Ubicación aproximada al distrito declarado.</a:t>
+              <a:t>Sin bancos: El Dorado, Lamas</a:t>
+            </a:r>
+          </a:p>
+          <a:p>
+            <a:pPr marL="0" indent="0">
+              <a:buNone/>
+            </a:pPr>
+            <a:r>
+              <a:rPr lang="es-PE" sz="900" dirty="0">
+                <a:solidFill>
+                  <a:srgbClr val="7A8699"/>
+                </a:solidFill>
+                <a:latin typeface="Calibri"/>
+              </a:rPr>
+              <a:t>Círculo = tipo I · cuadrado = tipo II · el número es la cantidad de bancos en un mismo punto. Ubicación aproximada al distrito declarado.</a:t>
             </a:r>
           </a:p>
         </p:txBody>
@@ -5447,7 +5641,7 @@
                 </a:solidFill>
                 <a:latin typeface="Calibri"/>
               </a:rPr>
-              <a:t>Tacna · ubicación de los bancos de sangre</a:t>
+              <a:t>Tacna · provincias y ubicación de los bancos de sangre</a:t>
             </a:r>
           </a:p>
         </p:txBody>
@@ -5484,8 +5678,8 @@
         </p:nvSpPr>
         <p:spPr>
           <a:xfrm>
-            <a:off x="8100000" y="1000000"/>
-            <a:ext cx="3800000" cy="5700000"/>
+            <a:off x="8100000" y="950000"/>
+            <a:ext cx="3900000" cy="5800000"/>
           </a:xfrm>
           <a:prstGeom prst="rect">
             <a:avLst/>
@@ -5516,7 +5710,7 @@
               <a:buChar char="•"/>
             </a:pPr>
             <a:r>
-              <a:rPr lang="es-PE" sz="1700" dirty="0">
+              <a:rPr lang="es-PE" sz="1600" dirty="0">
                 <a:solidFill>
                   <a:srgbClr val="C2334D"/>
                 </a:solidFill>
@@ -5531,7 +5725,7 @@
               <a:buChar char="•"/>
             </a:pPr>
             <a:r>
-              <a:rPr lang="es-PE" sz="1700" dirty="0">
+              <a:rPr lang="es-PE" sz="1600" dirty="0">
                 <a:solidFill>
                   <a:srgbClr val="1F6F8B"/>
                 </a:solidFill>
@@ -5546,7 +5740,7 @@
               <a:buChar char="•"/>
             </a:pPr>
             <a:r>
-              <a:rPr lang="es-PE" sz="1700" dirty="0">
+              <a:rPr lang="es-PE" sz="1600" dirty="0">
                 <a:solidFill>
                   <a:srgbClr val="B7791F"/>
                 </a:solidFill>
@@ -5561,7 +5755,7 @@
               <a:buChar char="•"/>
             </a:pPr>
             <a:r>
-              <a:rPr lang="es-PE" sz="1700" dirty="0">
+              <a:rPr lang="es-PE" sz="1600" dirty="0">
                 <a:solidFill>
                   <a:srgbClr val="2F6B3F"/>
                 </a:solidFill>
@@ -5575,13 +5769,13 @@
               <a:buNone/>
             </a:pPr>
             <a:r>
-              <a:rPr lang="es-PE" sz="1400" b="1" dirty="0">
+              <a:rPr lang="es-PE" sz="1300" b="1" dirty="0">
                 <a:solidFill>
                   <a:srgbClr val="445066"/>
                 </a:solidFill>
                 <a:latin typeface="Calibri"/>
               </a:rPr>
-              <a:t>Principales provincias</a:t>
+              <a:t>Provincias: 4 (con banco: 1)</a:t>
             </a:r>
           </a:p>
           <a:p>
@@ -5610,7 +5804,21 @@
                 </a:solidFill>
                 <a:latin typeface="Calibri"/>
               </a:rPr>
-              <a:t>Círculo = tipo I · cuadrado = tipo II. Ubicación aproximada al distrito declarado.</a:t>
+              <a:t>Sin bancos: Candarave, Jorge Basadre, Tarata</a:t>
+            </a:r>
+          </a:p>
+          <a:p>
+            <a:pPr marL="0" indent="0">
+              <a:buNone/>
+            </a:pPr>
+            <a:r>
+              <a:rPr lang="es-PE" sz="900" dirty="0">
+                <a:solidFill>
+                  <a:srgbClr val="7A8699"/>
+                </a:solidFill>
+                <a:latin typeface="Calibri"/>
+              </a:rPr>
+              <a:t>Círculo = tipo I · cuadrado = tipo II · el número es la cantidad de bancos en un mismo punto. Ubicación aproximada al distrito declarado.</a:t>
             </a:r>
           </a:p>
         </p:txBody>
@@ -5671,7 +5879,7 @@
                 </a:solidFill>
                 <a:latin typeface="Calibri"/>
               </a:rPr>
-              <a:t>Tumbes · ubicación de los bancos de sangre</a:t>
+              <a:t>Tumbes · provincias y ubicación de los bancos de sangre</a:t>
             </a:r>
           </a:p>
         </p:txBody>
@@ -5708,8 +5916,8 @@
         </p:nvSpPr>
         <p:spPr>
           <a:xfrm>
-            <a:off x="8100000" y="1000000"/>
-            <a:ext cx="3800000" cy="5700000"/>
+            <a:off x="8100000" y="950000"/>
+            <a:ext cx="3900000" cy="5800000"/>
           </a:xfrm>
           <a:prstGeom prst="rect">
             <a:avLst/>
@@ -5740,7 +5948,7 @@
               <a:buChar char="•"/>
             </a:pPr>
             <a:r>
-              <a:rPr lang="es-PE" sz="1700" dirty="0">
+              <a:rPr lang="es-PE" sz="1600" dirty="0">
                 <a:solidFill>
                   <a:srgbClr val="C2334D"/>
                 </a:solidFill>
@@ -5755,7 +5963,7 @@
               <a:buChar char="•"/>
             </a:pPr>
             <a:r>
-              <a:rPr lang="es-PE" sz="1700" dirty="0">
+              <a:rPr lang="es-PE" sz="1600" dirty="0">
                 <a:solidFill>
                   <a:srgbClr val="1F6F8B"/>
                 </a:solidFill>
@@ -5770,7 +5978,7 @@
               <a:buChar char="•"/>
             </a:pPr>
             <a:r>
-              <a:rPr lang="es-PE" sz="1700" dirty="0">
+              <a:rPr lang="es-PE" sz="1600" dirty="0">
                 <a:solidFill>
                   <a:srgbClr val="B7791F"/>
                 </a:solidFill>
@@ -5785,7 +5993,7 @@
               <a:buChar char="•"/>
             </a:pPr>
             <a:r>
-              <a:rPr lang="es-PE" sz="1700" dirty="0">
+              <a:rPr lang="es-PE" sz="1600" dirty="0">
                 <a:solidFill>
                   <a:srgbClr val="2F6B3F"/>
                 </a:solidFill>
@@ -5799,13 +6007,13 @@
               <a:buNone/>
             </a:pPr>
             <a:r>
-              <a:rPr lang="es-PE" sz="1400" b="1" dirty="0">
+              <a:rPr lang="es-PE" sz="1300" b="1" dirty="0">
                 <a:solidFill>
                   <a:srgbClr val="445066"/>
                 </a:solidFill>
                 <a:latin typeface="Calibri"/>
               </a:rPr>
-              <a:t>Principales provincias</a:t>
+              <a:t>Provincias: 3 (con banco: 1)</a:t>
             </a:r>
           </a:p>
           <a:p>
@@ -5834,7 +6042,21 @@
                 </a:solidFill>
                 <a:latin typeface="Calibri"/>
               </a:rPr>
-              <a:t>Círculo = tipo I · cuadrado = tipo II. Ubicación aproximada al distrito declarado.</a:t>
+              <a:t>Sin bancos: Contralmirante Villar, Zarumilla</a:t>
+            </a:r>
+          </a:p>
+          <a:p>
+            <a:pPr marL="0" indent="0">
+              <a:buNone/>
+            </a:pPr>
+            <a:r>
+              <a:rPr lang="es-PE" sz="900" dirty="0">
+                <a:solidFill>
+                  <a:srgbClr val="7A8699"/>
+                </a:solidFill>
+                <a:latin typeface="Calibri"/>
+              </a:rPr>
+              <a:t>Círculo = tipo I · cuadrado = tipo II · el número es la cantidad de bancos en un mismo punto. Ubicación aproximada al distrito declarado.</a:t>
             </a:r>
           </a:p>
         </p:txBody>
@@ -5895,7 +6117,7 @@
                 </a:solidFill>
                 <a:latin typeface="Calibri"/>
               </a:rPr>
-              <a:t>Ucayali · ubicación de los bancos de sangre</a:t>
+              <a:t>Ucayali · provincias y ubicación de los bancos de sangre</a:t>
             </a:r>
           </a:p>
         </p:txBody>
@@ -5932,8 +6154,8 @@
         </p:nvSpPr>
         <p:spPr>
           <a:xfrm>
-            <a:off x="8100000" y="1000000"/>
-            <a:ext cx="3800000" cy="5700000"/>
+            <a:off x="8100000" y="950000"/>
+            <a:ext cx="3900000" cy="5800000"/>
           </a:xfrm>
           <a:prstGeom prst="rect">
             <a:avLst/>
@@ -5964,7 +6186,7 @@
               <a:buChar char="•"/>
             </a:pPr>
             <a:r>
-              <a:rPr lang="es-PE" sz="1700" dirty="0">
+              <a:rPr lang="es-PE" sz="1600" dirty="0">
                 <a:solidFill>
                   <a:srgbClr val="C2334D"/>
                 </a:solidFill>
@@ -5979,7 +6201,7 @@
               <a:buChar char="•"/>
             </a:pPr>
             <a:r>
-              <a:rPr lang="es-PE" sz="1700" dirty="0">
+              <a:rPr lang="es-PE" sz="1600" dirty="0">
                 <a:solidFill>
                   <a:srgbClr val="1F6F8B"/>
                 </a:solidFill>
@@ -5994,7 +6216,7 @@
               <a:buChar char="•"/>
             </a:pPr>
             <a:r>
-              <a:rPr lang="es-PE" sz="1700" dirty="0">
+              <a:rPr lang="es-PE" sz="1600" dirty="0">
                 <a:solidFill>
                   <a:srgbClr val="B7791F"/>
                 </a:solidFill>
@@ -6009,7 +6231,7 @@
               <a:buChar char="•"/>
             </a:pPr>
             <a:r>
-              <a:rPr lang="es-PE" sz="1700" dirty="0">
+              <a:rPr lang="es-PE" sz="1600" dirty="0">
                 <a:solidFill>
                   <a:srgbClr val="2F6B3F"/>
                 </a:solidFill>
@@ -6023,13 +6245,13 @@
               <a:buNone/>
             </a:pPr>
             <a:r>
-              <a:rPr lang="es-PE" sz="1400" b="1" dirty="0">
+              <a:rPr lang="es-PE" sz="1300" b="1" dirty="0">
                 <a:solidFill>
                   <a:srgbClr val="445066"/>
                 </a:solidFill>
                 <a:latin typeface="Calibri"/>
               </a:rPr>
-              <a:t>Principales provincias</a:t>
+              <a:t>Provincias: 4 (con banco: 2)</a:t>
             </a:r>
           </a:p>
           <a:p>
@@ -6073,7 +6295,21 @@
                 </a:solidFill>
                 <a:latin typeface="Calibri"/>
               </a:rPr>
-              <a:t>Círculo = tipo I · cuadrado = tipo II. Ubicación aproximada al distrito declarado.</a:t>
+              <a:t>Sin bancos: Padre Abad, Purus</a:t>
+            </a:r>
+          </a:p>
+          <a:p>
+            <a:pPr marL="0" indent="0">
+              <a:buNone/>
+            </a:pPr>
+            <a:r>
+              <a:rPr lang="es-PE" sz="900" dirty="0">
+                <a:solidFill>
+                  <a:srgbClr val="7A8699"/>
+                </a:solidFill>
+                <a:latin typeface="Calibri"/>
+              </a:rPr>
+              <a:t>Círculo = tipo I · cuadrado = tipo II · el número es la cantidad de bancos en un mismo punto. Ubicación aproximada al distrito declarado.</a:t>
             </a:r>
           </a:p>
         </p:txBody>
@@ -9965,7 +10201,7 @@
                 </a:solidFill>
                 <a:latin typeface="Calibri"/>
               </a:rPr>
-              <a:t>Amazonas · ubicación de los bancos de sangre</a:t>
+              <a:t>Amazonas · provincias y ubicación de los bancos de sangre</a:t>
             </a:r>
           </a:p>
         </p:txBody>
@@ -10002,8 +10238,8 @@
         </p:nvSpPr>
         <p:spPr>
           <a:xfrm>
-            <a:off x="8100000" y="1000000"/>
-            <a:ext cx="3800000" cy="5700000"/>
+            <a:off x="8100000" y="950000"/>
+            <a:ext cx="3900000" cy="5800000"/>
           </a:xfrm>
           <a:prstGeom prst="rect">
             <a:avLst/>
@@ -10034,7 +10270,7 @@
               <a:buChar char="•"/>
             </a:pPr>
             <a:r>
-              <a:rPr lang="es-PE" sz="1700" dirty="0">
+              <a:rPr lang="es-PE" sz="1600" dirty="0">
                 <a:solidFill>
                   <a:srgbClr val="C2334D"/>
                 </a:solidFill>
@@ -10049,7 +10285,7 @@
               <a:buChar char="•"/>
             </a:pPr>
             <a:r>
-              <a:rPr lang="es-PE" sz="1700" dirty="0">
+              <a:rPr lang="es-PE" sz="1600" dirty="0">
                 <a:solidFill>
                   <a:srgbClr val="1F6F8B"/>
                 </a:solidFill>
@@ -10064,7 +10300,7 @@
               <a:buChar char="•"/>
             </a:pPr>
             <a:r>
-              <a:rPr lang="es-PE" sz="1700" dirty="0">
+              <a:rPr lang="es-PE" sz="1600" dirty="0">
                 <a:solidFill>
                   <a:srgbClr val="B7791F"/>
                 </a:solidFill>
@@ -10079,7 +10315,7 @@
               <a:buChar char="•"/>
             </a:pPr>
             <a:r>
-              <a:rPr lang="es-PE" sz="1700" dirty="0">
+              <a:rPr lang="es-PE" sz="1600" dirty="0">
                 <a:solidFill>
                   <a:srgbClr val="2F6B3F"/>
                 </a:solidFill>
@@ -10093,13 +10329,13 @@
               <a:buNone/>
             </a:pPr>
             <a:r>
-              <a:rPr lang="es-PE" sz="1400" b="1" dirty="0">
+              <a:rPr lang="es-PE" sz="1300" b="1" dirty="0">
                 <a:solidFill>
                   <a:srgbClr val="445066"/>
                 </a:solidFill>
                 <a:latin typeface="Calibri"/>
               </a:rPr>
-              <a:t>Principales provincias</a:t>
+              <a:t>Provincias: 7 (con banco: 4)</a:t>
             </a:r>
           </a:p>
           <a:p>
@@ -10114,6 +10350,21 @@
                 </a:solidFill>
                 <a:latin typeface="Calibri"/>
               </a:rPr>
+              <a:t>Bagua: 3</a:t>
+            </a:r>
+          </a:p>
+          <a:p>
+            <a:pPr marL="0" indent="0">
+              <a:buFont typeface="Arial"/>
+              <a:buChar char="•"/>
+            </a:pPr>
+            <a:r>
+              <a:rPr lang="es-PE" sz="1200" dirty="0">
+                <a:solidFill>
+                  <a:srgbClr val="223344"/>
+                </a:solidFill>
+                <a:latin typeface="Calibri"/>
+              </a:rPr>
               <a:t>Utcubamba: 3</a:t>
             </a:r>
           </a:p>
@@ -10129,7 +10380,7 @@
                 </a:solidFill>
                 <a:latin typeface="Calibri"/>
               </a:rPr>
-              <a:t>Bagua: 3</a:t>
+              <a:t>Chachapoyas: 2</a:t>
             </a:r>
           </a:p>
           <a:p>
@@ -10144,21 +10395,6 @@
                 </a:solidFill>
                 <a:latin typeface="Calibri"/>
               </a:rPr>
-              <a:t>Chachapoyas: 2</a:t>
-            </a:r>
-          </a:p>
-          <a:p>
-            <a:pPr marL="0" indent="0">
-              <a:buFont typeface="Arial"/>
-              <a:buChar char="•"/>
-            </a:pPr>
-            <a:r>
-              <a:rPr lang="es-PE" sz="1200" dirty="0">
-                <a:solidFill>
-                  <a:srgbClr val="223344"/>
-                </a:solidFill>
-                <a:latin typeface="Calibri"/>
-              </a:rPr>
               <a:t>Condorcanqui: 1</a:t>
             </a:r>
           </a:p>
@@ -10173,7 +10409,21 @@
                 </a:solidFill>
                 <a:latin typeface="Calibri"/>
               </a:rPr>
-              <a:t>Círculo = tipo I · cuadrado = tipo II. Ubicación aproximada al distrito declarado.</a:t>
+              <a:t>Sin bancos: Bongara, Luya, Rodriguez De Mendoza</a:t>
+            </a:r>
+          </a:p>
+          <a:p>
+            <a:pPr marL="0" indent="0">
+              <a:buNone/>
+            </a:pPr>
+            <a:r>
+              <a:rPr lang="es-PE" sz="900" dirty="0">
+                <a:solidFill>
+                  <a:srgbClr val="7A8699"/>
+                </a:solidFill>
+                <a:latin typeface="Calibri"/>
+              </a:rPr>
+              <a:t>Círculo = tipo I · cuadrado = tipo II · el número es la cantidad de bancos en un mismo punto. Ubicación aproximada al distrito declarado.</a:t>
             </a:r>
           </a:p>
         </p:txBody>
@@ -10234,7 +10484,7 @@
                 </a:solidFill>
                 <a:latin typeface="Calibri"/>
               </a:rPr>
-              <a:t>Áncash · ubicación de los bancos de sangre</a:t>
+              <a:t>Áncash · provincias y ubicación de los bancos de sangre</a:t>
             </a:r>
           </a:p>
         </p:txBody>
@@ -10271,8 +10521,8 @@
         </p:nvSpPr>
         <p:spPr>
           <a:xfrm>
-            <a:off x="8100000" y="1000000"/>
-            <a:ext cx="3800000" cy="5700000"/>
+            <a:off x="8100000" y="950000"/>
+            <a:ext cx="3900000" cy="5800000"/>
           </a:xfrm>
           <a:prstGeom prst="rect">
             <a:avLst/>
@@ -10303,7 +10553,7 @@
               <a:buChar char="•"/>
             </a:pPr>
             <a:r>
-              <a:rPr lang="es-PE" sz="1700" dirty="0">
+              <a:rPr lang="es-PE" sz="1600" dirty="0">
                 <a:solidFill>
                   <a:srgbClr val="C2334D"/>
                 </a:solidFill>
@@ -10318,7 +10568,7 @@
               <a:buChar char="•"/>
             </a:pPr>
             <a:r>
-              <a:rPr lang="es-PE" sz="1700" dirty="0">
+              <a:rPr lang="es-PE" sz="1600" dirty="0">
                 <a:solidFill>
                   <a:srgbClr val="1F6F8B"/>
                 </a:solidFill>
@@ -10333,7 +10583,7 @@
               <a:buChar char="•"/>
             </a:pPr>
             <a:r>
-              <a:rPr lang="es-PE" sz="1700" dirty="0">
+              <a:rPr lang="es-PE" sz="1600" dirty="0">
                 <a:solidFill>
                   <a:srgbClr val="B7791F"/>
                 </a:solidFill>
@@ -10348,7 +10598,7 @@
               <a:buChar char="•"/>
             </a:pPr>
             <a:r>
-              <a:rPr lang="es-PE" sz="1700" dirty="0">
+              <a:rPr lang="es-PE" sz="1600" dirty="0">
                 <a:solidFill>
                   <a:srgbClr val="2F6B3F"/>
                 </a:solidFill>
@@ -10362,13 +10612,13 @@
               <a:buNone/>
             </a:pPr>
             <a:r>
-              <a:rPr lang="es-PE" sz="1400" b="1" dirty="0">
+              <a:rPr lang="es-PE" sz="1300" b="1" dirty="0">
                 <a:solidFill>
                   <a:srgbClr val="445066"/>
                 </a:solidFill>
                 <a:latin typeface="Calibri"/>
               </a:rPr>
-              <a:t>Principales provincias</a:t>
+              <a:t>Provincias: 20 (con banco: 10)</a:t>
             </a:r>
           </a:p>
           <a:p>
@@ -10413,86 +10663,116 @@
                 </a:solidFill>
                 <a:latin typeface="Calibri"/>
               </a:rPr>
+              <a:t>Carhuaz: 1</a:t>
+            </a:r>
+          </a:p>
+          <a:p>
+            <a:pPr marL="0" indent="0">
+              <a:buFont typeface="Arial"/>
+              <a:buChar char="•"/>
+            </a:pPr>
+            <a:r>
+              <a:rPr lang="es-PE" sz="1200" dirty="0">
+                <a:solidFill>
+                  <a:srgbClr val="223344"/>
+                </a:solidFill>
+                <a:latin typeface="Calibri"/>
+              </a:rPr>
+              <a:t>Casma: 1</a:t>
+            </a:r>
+          </a:p>
+          <a:p>
+            <a:pPr marL="0" indent="0">
+              <a:buFont typeface="Arial"/>
+              <a:buChar char="•"/>
+            </a:pPr>
+            <a:r>
+              <a:rPr lang="es-PE" sz="1200" dirty="0">
+                <a:solidFill>
+                  <a:srgbClr val="223344"/>
+                </a:solidFill>
+                <a:latin typeface="Calibri"/>
+              </a:rPr>
+              <a:t>Huari: 1</a:t>
+            </a:r>
+          </a:p>
+          <a:p>
+            <a:pPr marL="0" indent="0">
+              <a:buFont typeface="Arial"/>
+              <a:buChar char="•"/>
+            </a:pPr>
+            <a:r>
+              <a:rPr lang="es-PE" sz="1200" dirty="0">
+                <a:solidFill>
+                  <a:srgbClr val="223344"/>
+                </a:solidFill>
+                <a:latin typeface="Calibri"/>
+              </a:rPr>
+              <a:t>Huarmey: 1</a:t>
+            </a:r>
+          </a:p>
+          <a:p>
+            <a:pPr marL="0" indent="0">
+              <a:buFont typeface="Arial"/>
+              <a:buChar char="•"/>
+            </a:pPr>
+            <a:r>
+              <a:rPr lang="es-PE" sz="1200" dirty="0">
+                <a:solidFill>
+                  <a:srgbClr val="223344"/>
+                </a:solidFill>
+                <a:latin typeface="Calibri"/>
+              </a:rPr>
+              <a:t>Huaylas: 1</a:t>
+            </a:r>
+          </a:p>
+          <a:p>
+            <a:pPr marL="0" indent="0">
+              <a:buFont typeface="Arial"/>
+              <a:buChar char="•"/>
+            </a:pPr>
+            <a:r>
+              <a:rPr lang="es-PE" sz="1200" dirty="0">
+                <a:solidFill>
+                  <a:srgbClr val="223344"/>
+                </a:solidFill>
+                <a:latin typeface="Calibri"/>
+              </a:rPr>
+              <a:t>Pomabamba: 1</a:t>
+            </a:r>
+          </a:p>
+          <a:p>
+            <a:pPr marL="0" indent="0">
+              <a:buFont typeface="Arial"/>
+              <a:buChar char="•"/>
+            </a:pPr>
+            <a:r>
+              <a:rPr lang="es-PE" sz="1200" dirty="0">
+                <a:solidFill>
+                  <a:srgbClr val="223344"/>
+                </a:solidFill>
+                <a:latin typeface="Calibri"/>
+              </a:rPr>
+              <a:t>Recuay: 1</a:t>
+            </a:r>
+          </a:p>
+          <a:p>
+            <a:pPr marL="0" indent="0">
+              <a:buFont typeface="Arial"/>
+              <a:buChar char="•"/>
+            </a:pPr>
+            <a:r>
+              <a:rPr lang="es-PE" sz="1200" dirty="0">
+                <a:solidFill>
+                  <a:srgbClr val="223344"/>
+                </a:solidFill>
+                <a:latin typeface="Calibri"/>
+              </a:rPr>
               <a:t>Yungay: 1</a:t>
             </a:r>
           </a:p>
           <a:p>
             <a:pPr marL="0" indent="0">
-              <a:buFont typeface="Arial"/>
-              <a:buChar char="•"/>
-            </a:pPr>
-            <a:r>
-              <a:rPr lang="es-PE" sz="1200" dirty="0">
-                <a:solidFill>
-                  <a:srgbClr val="223344"/>
-                </a:solidFill>
-                <a:latin typeface="Calibri"/>
-              </a:rPr>
-              <a:t>Carhuaz: 1</a:t>
-            </a:r>
-          </a:p>
-          <a:p>
-            <a:pPr marL="0" indent="0">
-              <a:buFont typeface="Arial"/>
-              <a:buChar char="•"/>
-            </a:pPr>
-            <a:r>
-              <a:rPr lang="es-PE" sz="1200" dirty="0">
-                <a:solidFill>
-                  <a:srgbClr val="223344"/>
-                </a:solidFill>
-                <a:latin typeface="Calibri"/>
-              </a:rPr>
-              <a:t>Pomabamba: 1</a:t>
-            </a:r>
-          </a:p>
-          <a:p>
-            <a:pPr marL="0" indent="0">
-              <a:buFont typeface="Arial"/>
-              <a:buChar char="•"/>
-            </a:pPr>
-            <a:r>
-              <a:rPr lang="es-PE" sz="1200" dirty="0">
-                <a:solidFill>
-                  <a:srgbClr val="223344"/>
-                </a:solidFill>
-                <a:latin typeface="Calibri"/>
-              </a:rPr>
-              <a:t>Casma: 1</a:t>
-            </a:r>
-          </a:p>
-          <a:p>
-            <a:pPr marL="0" indent="0">
-              <a:buFont typeface="Arial"/>
-              <a:buChar char="•"/>
-            </a:pPr>
-            <a:r>
-              <a:rPr lang="es-PE" sz="1200" dirty="0">
-                <a:solidFill>
-                  <a:srgbClr val="223344"/>
-                </a:solidFill>
-                <a:latin typeface="Calibri"/>
-              </a:rPr>
-              <a:t>Huaylas: 1</a:t>
-            </a:r>
-          </a:p>
-          <a:p>
-            <a:pPr marL="0" indent="0">
-              <a:buFont typeface="Arial"/>
-              <a:buChar char="•"/>
-            </a:pPr>
-            <a:r>
-              <a:rPr lang="es-PE" sz="1200" dirty="0">
-                <a:solidFill>
-                  <a:srgbClr val="223344"/>
-                </a:solidFill>
-                <a:latin typeface="Calibri"/>
-              </a:rPr>
-              <a:t>Recuay: 1</a:t>
-            </a:r>
-          </a:p>
-          <a:p>
-            <a:pPr marL="0" indent="0">
               <a:buNone/>
             </a:pPr>
             <a:r>
@@ -10502,7 +10782,21 @@
                 </a:solidFill>
                 <a:latin typeface="Calibri"/>
               </a:rPr>
-              <a:t>Círculo = tipo I · cuadrado = tipo II. Ubicación aproximada al distrito declarado.</a:t>
+              <a:t>Sin bancos: Aija, Antonio Raymondi, Asuncion, Bolognesi, Carlos Fermin Fitzcarrald, Corongo, Mariscal Luzuriaga, Ocros, Pallasca, Sihuas</a:t>
+            </a:r>
+          </a:p>
+          <a:p>
+            <a:pPr marL="0" indent="0">
+              <a:buNone/>
+            </a:pPr>
+            <a:r>
+              <a:rPr lang="es-PE" sz="900" dirty="0">
+                <a:solidFill>
+                  <a:srgbClr val="7A8699"/>
+                </a:solidFill>
+                <a:latin typeface="Calibri"/>
+              </a:rPr>
+              <a:t>Círculo = tipo I · cuadrado = tipo II · el número es la cantidad de bancos en un mismo punto. Ubicación aproximada al distrito declarado.</a:t>
             </a:r>
           </a:p>
         </p:txBody>
@@ -10563,7 +10857,7 @@
                 </a:solidFill>
                 <a:latin typeface="Calibri"/>
               </a:rPr>
-              <a:t>Apurímac · ubicación de los bancos de sangre</a:t>
+              <a:t>Apurímac · provincias y ubicación de los bancos de sangre</a:t>
             </a:r>
           </a:p>
         </p:txBody>
@@ -10600,8 +10894,8 @@
         </p:nvSpPr>
         <p:spPr>
           <a:xfrm>
-            <a:off x="8100000" y="1000000"/>
-            <a:ext cx="3800000" cy="5700000"/>
+            <a:off x="8100000" y="950000"/>
+            <a:ext cx="3900000" cy="5800000"/>
           </a:xfrm>
           <a:prstGeom prst="rect">
             <a:avLst/>
@@ -10632,7 +10926,7 @@
               <a:buChar char="•"/>
             </a:pPr>
             <a:r>
-              <a:rPr lang="es-PE" sz="1700" dirty="0">
+              <a:rPr lang="es-PE" sz="1600" dirty="0">
                 <a:solidFill>
                   <a:srgbClr val="C2334D"/>
                 </a:solidFill>
@@ -10647,7 +10941,7 @@
               <a:buChar char="•"/>
             </a:pPr>
             <a:r>
-              <a:rPr lang="es-PE" sz="1700" dirty="0">
+              <a:rPr lang="es-PE" sz="1600" dirty="0">
                 <a:solidFill>
                   <a:srgbClr val="1F6F8B"/>
                 </a:solidFill>
@@ -10662,7 +10956,7 @@
               <a:buChar char="•"/>
             </a:pPr>
             <a:r>
-              <a:rPr lang="es-PE" sz="1700" dirty="0">
+              <a:rPr lang="es-PE" sz="1600" dirty="0">
                 <a:solidFill>
                   <a:srgbClr val="B7791F"/>
                 </a:solidFill>
@@ -10677,7 +10971,7 @@
               <a:buChar char="•"/>
             </a:pPr>
             <a:r>
-              <a:rPr lang="es-PE" sz="1700" dirty="0">
+              <a:rPr lang="es-PE" sz="1600" dirty="0">
                 <a:solidFill>
                   <a:srgbClr val="2F6B3F"/>
                 </a:solidFill>
@@ -10691,13 +10985,13 @@
               <a:buNone/>
             </a:pPr>
             <a:r>
-              <a:rPr lang="es-PE" sz="1400" b="1" dirty="0">
+              <a:rPr lang="es-PE" sz="1300" b="1" dirty="0">
                 <a:solidFill>
                   <a:srgbClr val="445066"/>
                 </a:solidFill>
                 <a:latin typeface="Calibri"/>
               </a:rPr>
-              <a:t>Principales provincias</a:t>
+              <a:t>Provincias: 7 (con banco: 3)</a:t>
             </a:r>
           </a:p>
           <a:p>
@@ -10756,7 +11050,21 @@
                 </a:solidFill>
                 <a:latin typeface="Calibri"/>
               </a:rPr>
-              <a:t>Círculo = tipo I · cuadrado = tipo II. Ubicación aproximada al distrito declarado.</a:t>
+              <a:t>Sin bancos: Antabamba, Aymaraes, Cotabambas, Grau</a:t>
+            </a:r>
+          </a:p>
+          <a:p>
+            <a:pPr marL="0" indent="0">
+              <a:buNone/>
+            </a:pPr>
+            <a:r>
+              <a:rPr lang="es-PE" sz="900" dirty="0">
+                <a:solidFill>
+                  <a:srgbClr val="7A8699"/>
+                </a:solidFill>
+                <a:latin typeface="Calibri"/>
+              </a:rPr>
+              <a:t>Círculo = tipo I · cuadrado = tipo II · el número es la cantidad de bancos en un mismo punto. Ubicación aproximada al distrito declarado.</a:t>
             </a:r>
           </a:p>
         </p:txBody>
@@ -10817,7 +11125,7 @@
                 </a:solidFill>
                 <a:latin typeface="Calibri"/>
               </a:rPr>
-              <a:t>Arequipa · ubicación de los bancos de sangre</a:t>
+              <a:t>Arequipa · provincias y ubicación de los bancos de sangre</a:t>
             </a:r>
           </a:p>
         </p:txBody>
@@ -10854,8 +11162,8 @@
         </p:nvSpPr>
         <p:spPr>
           <a:xfrm>
-            <a:off x="8100000" y="1000000"/>
-            <a:ext cx="3800000" cy="5700000"/>
+            <a:off x="8100000" y="950000"/>
+            <a:ext cx="3900000" cy="5800000"/>
           </a:xfrm>
           <a:prstGeom prst="rect">
             <a:avLst/>
@@ -10886,7 +11194,7 @@
               <a:buChar char="•"/>
             </a:pPr>
             <a:r>
-              <a:rPr lang="es-PE" sz="1700" dirty="0">
+              <a:rPr lang="es-PE" sz="1600" dirty="0">
                 <a:solidFill>
                   <a:srgbClr val="C2334D"/>
                 </a:solidFill>
@@ -10901,7 +11209,7 @@
               <a:buChar char="•"/>
             </a:pPr>
             <a:r>
-              <a:rPr lang="es-PE" sz="1700" dirty="0">
+              <a:rPr lang="es-PE" sz="1600" dirty="0">
                 <a:solidFill>
                   <a:srgbClr val="1F6F8B"/>
                 </a:solidFill>
@@ -10916,7 +11224,7 @@
               <a:buChar char="•"/>
             </a:pPr>
             <a:r>
-              <a:rPr lang="es-PE" sz="1700" dirty="0">
+              <a:rPr lang="es-PE" sz="1600" dirty="0">
                 <a:solidFill>
                   <a:srgbClr val="B7791F"/>
                 </a:solidFill>
@@ -10931,7 +11239,7 @@
               <a:buChar char="•"/>
             </a:pPr>
             <a:r>
-              <a:rPr lang="es-PE" sz="1700" dirty="0">
+              <a:rPr lang="es-PE" sz="1600" dirty="0">
                 <a:solidFill>
                   <a:srgbClr val="2F6B3F"/>
                 </a:solidFill>
@@ -10945,13 +11253,13 @@
               <a:buNone/>
             </a:pPr>
             <a:r>
-              <a:rPr lang="es-PE" sz="1400" b="1" dirty="0">
+              <a:rPr lang="es-PE" sz="1300" b="1" dirty="0">
                 <a:solidFill>
                   <a:srgbClr val="445066"/>
                 </a:solidFill>
                 <a:latin typeface="Calibri"/>
               </a:rPr>
-              <a:t>Principales provincias</a:t>
+              <a:t>Provincias: 8 (con banco: 4)</a:t>
             </a:r>
           </a:p>
           <a:p>
@@ -10996,26 +11304,26 @@
                 </a:solidFill>
                 <a:latin typeface="Calibri"/>
               </a:rPr>
+              <a:t>Camana: 1</a:t>
+            </a:r>
+          </a:p>
+          <a:p>
+            <a:pPr marL="0" indent="0">
+              <a:buFont typeface="Arial"/>
+              <a:buChar char="•"/>
+            </a:pPr>
+            <a:r>
+              <a:rPr lang="es-PE" sz="1200" dirty="0">
+                <a:solidFill>
+                  <a:srgbClr val="223344"/>
+                </a:solidFill>
+                <a:latin typeface="Calibri"/>
+              </a:rPr>
               <a:t>Caylloma: 1</a:t>
             </a:r>
           </a:p>
           <a:p>
             <a:pPr marL="0" indent="0">
-              <a:buFont typeface="Arial"/>
-              <a:buChar char="•"/>
-            </a:pPr>
-            <a:r>
-              <a:rPr lang="es-PE" sz="1200" dirty="0">
-                <a:solidFill>
-                  <a:srgbClr val="223344"/>
-                </a:solidFill>
-                <a:latin typeface="Calibri"/>
-              </a:rPr>
-              <a:t>Camana: 1</a:t>
-            </a:r>
-          </a:p>
-          <a:p>
-            <a:pPr marL="0" indent="0">
               <a:buNone/>
             </a:pPr>
             <a:r>
@@ -11025,7 +11333,21 @@
                 </a:solidFill>
                 <a:latin typeface="Calibri"/>
               </a:rPr>
-              <a:t>Círculo = tipo I · cuadrado = tipo II. Ubicación aproximada al distrito declarado.</a:t>
+              <a:t>Sin bancos: Caraveli, Castilla, Condesuyos, La Union</a:t>
+            </a:r>
+          </a:p>
+          <a:p>
+            <a:pPr marL="0" indent="0">
+              <a:buNone/>
+            </a:pPr>
+            <a:r>
+              <a:rPr lang="es-PE" sz="900" dirty="0">
+                <a:solidFill>
+                  <a:srgbClr val="7A8699"/>
+                </a:solidFill>
+                <a:latin typeface="Calibri"/>
+              </a:rPr>
+              <a:t>Círculo = tipo I · cuadrado = tipo II · el número es la cantidad de bancos en un mismo punto. Ubicación aproximada al distrito declarado.</a:t>
             </a:r>
           </a:p>
         </p:txBody>
@@ -11086,7 +11408,7 @@
                 </a:solidFill>
                 <a:latin typeface="Calibri"/>
               </a:rPr>
-              <a:t>Ayacucho · ubicación de los bancos de sangre</a:t>
+              <a:t>Ayacucho · provincias y ubicación de los bancos de sangre</a:t>
             </a:r>
           </a:p>
         </p:txBody>
@@ -11123,8 +11445,8 @@
         </p:nvSpPr>
         <p:spPr>
           <a:xfrm>
-            <a:off x="8100000" y="1000000"/>
-            <a:ext cx="3800000" cy="5700000"/>
+            <a:off x="8100000" y="950000"/>
+            <a:ext cx="3900000" cy="5800000"/>
           </a:xfrm>
           <a:prstGeom prst="rect">
             <a:avLst/>
@@ -11155,7 +11477,7 @@
               <a:buChar char="•"/>
             </a:pPr>
             <a:r>
-              <a:rPr lang="es-PE" sz="1700" dirty="0">
+              <a:rPr lang="es-PE" sz="1600" dirty="0">
                 <a:solidFill>
                   <a:srgbClr val="C2334D"/>
                 </a:solidFill>
@@ -11170,7 +11492,7 @@
               <a:buChar char="•"/>
             </a:pPr>
             <a:r>
-              <a:rPr lang="es-PE" sz="1700" dirty="0">
+              <a:rPr lang="es-PE" sz="1600" dirty="0">
                 <a:solidFill>
                   <a:srgbClr val="1F6F8B"/>
                 </a:solidFill>
@@ -11185,7 +11507,7 @@
               <a:buChar char="•"/>
             </a:pPr>
             <a:r>
-              <a:rPr lang="es-PE" sz="1700" dirty="0">
+              <a:rPr lang="es-PE" sz="1600" dirty="0">
                 <a:solidFill>
                   <a:srgbClr val="B7791F"/>
                 </a:solidFill>
@@ -11200,7 +11522,7 @@
               <a:buChar char="•"/>
             </a:pPr>
             <a:r>
-              <a:rPr lang="es-PE" sz="1700" dirty="0">
+              <a:rPr lang="es-PE" sz="1600" dirty="0">
                 <a:solidFill>
                   <a:srgbClr val="2F6B3F"/>
                 </a:solidFill>
@@ -11214,13 +11536,13 @@
               <a:buNone/>
             </a:pPr>
             <a:r>
-              <a:rPr lang="es-PE" sz="1400" b="1" dirty="0">
+              <a:rPr lang="es-PE" sz="1300" b="1" dirty="0">
                 <a:solidFill>
                   <a:srgbClr val="445066"/>
                 </a:solidFill>
                 <a:latin typeface="Calibri"/>
               </a:rPr>
-              <a:t>Principales provincias</a:t>
+              <a:t>Provincias: 12 (con banco: 6)</a:t>
             </a:r>
           </a:p>
           <a:p>
@@ -11265,6 +11587,36 @@
                 </a:solidFill>
                 <a:latin typeface="Calibri"/>
               </a:rPr>
+              <a:t>Cangallo: 1</a:t>
+            </a:r>
+          </a:p>
+          <a:p>
+            <a:pPr marL="0" indent="0">
+              <a:buFont typeface="Arial"/>
+              <a:buChar char="•"/>
+            </a:pPr>
+            <a:r>
+              <a:rPr lang="es-PE" sz="1200" dirty="0">
+                <a:solidFill>
+                  <a:srgbClr val="223344"/>
+                </a:solidFill>
+                <a:latin typeface="Calibri"/>
+              </a:rPr>
+              <a:t>Huanta: 1</a:t>
+            </a:r>
+          </a:p>
+          <a:p>
+            <a:pPr marL="0" indent="0">
+              <a:buFont typeface="Arial"/>
+              <a:buChar char="•"/>
+            </a:pPr>
+            <a:r>
+              <a:rPr lang="es-PE" sz="1200" dirty="0">
+                <a:solidFill>
+                  <a:srgbClr val="223344"/>
+                </a:solidFill>
+                <a:latin typeface="Calibri"/>
+              </a:rPr>
               <a:t>Lucanas: 1</a:t>
             </a:r>
           </a:p>
@@ -11280,37 +11632,7 @@
                 </a:solidFill>
                 <a:latin typeface="Calibri"/>
               </a:rPr>
-              <a:t>Cangallo: 1</a:t>
-            </a:r>
-          </a:p>
-          <a:p>
-            <a:pPr marL="0" indent="0">
-              <a:buFont typeface="Arial"/>
-              <a:buChar char="•"/>
-            </a:pPr>
-            <a:r>
-              <a:rPr lang="es-PE" sz="1200" dirty="0">
-                <a:solidFill>
-                  <a:srgbClr val="223344"/>
-                </a:solidFill>
-                <a:latin typeface="Calibri"/>
-              </a:rPr>
-              <a:t>Huanta: 1</a:t>
-            </a:r>
-          </a:p>
-          <a:p>
-            <a:pPr marL="0" indent="0">
-              <a:buFont typeface="Arial"/>
-              <a:buChar char="•"/>
-            </a:pPr>
-            <a:r>
-              <a:rPr lang="es-PE" sz="1200" dirty="0">
-                <a:solidFill>
-                  <a:srgbClr val="223344"/>
-                </a:solidFill>
-                <a:latin typeface="Calibri"/>
-              </a:rPr>
-              <a:t>Coracora: 1</a:t>
+              <a:t>Parinacochas: 1</a:t>
             </a:r>
           </a:p>
           <a:p>
@@ -11324,7 +11646,21 @@
                 </a:solidFill>
                 <a:latin typeface="Calibri"/>
               </a:rPr>
-              <a:t>Círculo = tipo I · cuadrado = tipo II. Ubicación aproximada al distrito declarado.</a:t>
+              <a:t>Sin bancos: Huanca Sancos, Paucar Del Sara Sara, Sucre, Victor Fafardo, Victor Fajardo, Vilcas Huaman</a:t>
+            </a:r>
+          </a:p>
+          <a:p>
+            <a:pPr marL="0" indent="0">
+              <a:buNone/>
+            </a:pPr>
+            <a:r>
+              <a:rPr lang="es-PE" sz="900" dirty="0">
+                <a:solidFill>
+                  <a:srgbClr val="7A8699"/>
+                </a:solidFill>
+                <a:latin typeface="Calibri"/>
+              </a:rPr>
+              <a:t>Círculo = tipo I · cuadrado = tipo II · el número es la cantidad de bancos en un mismo punto. Ubicación aproximada al distrito declarado.</a:t>
             </a:r>
           </a:p>
         </p:txBody>

</xml_diff>

<commit_message>
Presentacion por region: solo bancos con estado AUTORIZADO (Matriz General de Autorizacion Sanitaria DIBAN)
Co-Authored-By: Claude Sonnet 5.5 <noreply@anthropic.com>
</commit_message>
<xml_diff>
--- a/datos/Bancos_de_sangre_por_region.pptx
+++ b/datos/Bancos_de_sangre_por_region.pptx
@@ -574,7 +574,7 @@
                 </a:solidFill>
                 <a:latin typeface="Calibri"/>
               </a:rPr>
-              <a:t>Registro Nacional de Bancos de Sangre Autorizados · DIBAN - MINSA</a:t>
+              <a:t>Bancos de sangre con estado AUTORIZADO · Matriz General de Autorización Sanitaria · DIBAN - MINSA</a:t>
             </a:r>
           </a:p>
         </p:txBody>
@@ -695,7 +695,7 @@
                 </a:solidFill>
                 <a:latin typeface="Calibri"/>
               </a:rPr>
-              <a:t>22 bancos de sangre</a:t>
+              <a:t>24 bancos de sangre</a:t>
             </a:r>
           </a:p>
           <a:p>
@@ -710,7 +710,7 @@
                 </a:solidFill>
                 <a:latin typeface="Calibri"/>
               </a:rPr>
-              <a:t>Tipo I-A: 17</a:t>
+              <a:t>Tipo I-A: 18</a:t>
             </a:r>
           </a:p>
           <a:p>
@@ -755,7 +755,7 @@
                 </a:solidFill>
                 <a:latin typeface="Calibri"/>
               </a:rPr>
-              <a:t>Tipo II: 2</a:t>
+              <a:t>Tipo II: 3</a:t>
             </a:r>
           </a:p>
           <a:p>
@@ -784,7 +784,7 @@
                 </a:solidFill>
                 <a:latin typeface="Calibri"/>
               </a:rPr>
-              <a:t>Jaen: 9</a:t>
+              <a:t>Jaen: 10</a:t>
             </a:r>
           </a:p>
           <a:p>
@@ -799,7 +799,7 @@
                 </a:solidFill>
                 <a:latin typeface="Calibri"/>
               </a:rPr>
-              <a:t>Cajamarca: 6</a:t>
+              <a:t>Cajamarca: 7</a:t>
             </a:r>
           </a:p>
           <a:p>
@@ -1008,7 +1008,7 @@
                 </a:solidFill>
                 <a:latin typeface="Calibri"/>
               </a:rPr>
-              <a:t>11 bancos de sangre</a:t>
+              <a:t>9 bancos de sangre</a:t>
             </a:r>
           </a:p>
           <a:p>
@@ -1023,7 +1023,7 @@
                 </a:solidFill>
                 <a:latin typeface="Calibri"/>
               </a:rPr>
-              <a:t>Tipo I-A: 2</a:t>
+              <a:t>Tipo I-A: 1</a:t>
             </a:r>
           </a:p>
           <a:p>
@@ -1068,7 +1068,7 @@
                 </a:solidFill>
                 <a:latin typeface="Calibri"/>
               </a:rPr>
-              <a:t>Tipo II: 4</a:t>
+              <a:t>Tipo II: 3</a:t>
             </a:r>
           </a:p>
           <a:p>
@@ -1097,7 +1097,7 @@
                 </a:solidFill>
                 <a:latin typeface="Calibri"/>
               </a:rPr>
-              <a:t>Callao: 11</a:t>
+              <a:t>Callao: 9</a:t>
             </a:r>
           </a:p>
           <a:p>
@@ -1813,7 +1813,7 @@
                 </a:solidFill>
                 <a:latin typeface="Calibri"/>
               </a:rPr>
-              <a:t>10 bancos de sangre</a:t>
+              <a:t>9 bancos de sangre</a:t>
             </a:r>
           </a:p>
           <a:p>
@@ -1828,7 +1828,7 @@
                 </a:solidFill>
                 <a:latin typeface="Calibri"/>
               </a:rPr>
-              <a:t>Tipo I-A: 7</a:t>
+              <a:t>Tipo I-A: 6</a:t>
             </a:r>
           </a:p>
           <a:p>
@@ -1902,7 +1902,7 @@
                 </a:solidFill>
                 <a:latin typeface="Calibri"/>
               </a:rPr>
-              <a:t>Huanuco: 7</a:t>
+              <a:t>Huanuco: 6</a:t>
             </a:r>
           </a:p>
           <a:p>
@@ -2349,7 +2349,7 @@
                 </a:solidFill>
                 <a:latin typeface="Calibri"/>
               </a:rPr>
-              <a:t>20 bancos de sangre</a:t>
+              <a:t>23 bancos de sangre</a:t>
             </a:r>
           </a:p>
           <a:p>
@@ -2364,7 +2364,7 @@
                 </a:solidFill>
                 <a:latin typeface="Calibri"/>
               </a:rPr>
-              <a:t>Tipo I-A: 11</a:t>
+              <a:t>Tipo I-A: 13</a:t>
             </a:r>
           </a:p>
           <a:p>
@@ -2409,7 +2409,7 @@
                 </a:solidFill>
                 <a:latin typeface="Calibri"/>
               </a:rPr>
-              <a:t>Tipo II: 4</a:t>
+              <a:t>Tipo II: 5</a:t>
             </a:r>
           </a:p>
           <a:p>
@@ -2438,7 +2438,7 @@
                 </a:solidFill>
                 <a:latin typeface="Calibri"/>
               </a:rPr>
-              <a:t>Huancayo: 12</a:t>
+              <a:t>Huancayo: 15</a:t>
             </a:r>
           </a:p>
           <a:p>
@@ -2677,7 +2677,7 @@
                 </a:solidFill>
                 <a:latin typeface="Calibri"/>
               </a:rPr>
-              <a:t>33 bancos de sangre</a:t>
+              <a:t>30 bancos de sangre</a:t>
             </a:r>
           </a:p>
           <a:p>
@@ -2692,7 +2692,7 @@
                 </a:solidFill>
                 <a:latin typeface="Calibri"/>
               </a:rPr>
-              <a:t>Tipo I-A: 20</a:t>
+              <a:t>Tipo I-A: 18</a:t>
             </a:r>
           </a:p>
           <a:p>
@@ -2722,7 +2722,7 @@
                 </a:solidFill>
                 <a:latin typeface="Calibri"/>
               </a:rPr>
-              <a:t>Tipo I-C: 2</a:t>
+              <a:t>Tipo I-C: 1</a:t>
             </a:r>
           </a:p>
           <a:p>
@@ -2766,7 +2766,7 @@
                 </a:solidFill>
                 <a:latin typeface="Calibri"/>
               </a:rPr>
-              <a:t>Trujillo: 26</a:t>
+              <a:t>Trujillo: 23</a:t>
             </a:r>
           </a:p>
           <a:p>
@@ -3273,7 +3273,7 @@
                 </a:solidFill>
                 <a:latin typeface="Calibri"/>
               </a:rPr>
-              <a:t>179 bancos de sangre</a:t>
+              <a:t>178 bancos de sangre</a:t>
             </a:r>
           </a:p>
           <a:p>
@@ -3288,7 +3288,7 @@
                 </a:solidFill>
                 <a:latin typeface="Calibri"/>
               </a:rPr>
-              <a:t>Tipo I-A: 103</a:t>
+              <a:t>Tipo I-A: 104</a:t>
             </a:r>
           </a:p>
           <a:p>
@@ -3318,7 +3318,7 @@
                 </a:solidFill>
                 <a:latin typeface="Calibri"/>
               </a:rPr>
-              <a:t>Tipo I-C: 11</a:t>
+              <a:t>Tipo I-C: 10</a:t>
             </a:r>
           </a:p>
           <a:p>
@@ -3333,7 +3333,7 @@
                 </a:solidFill>
                 <a:latin typeface="Calibri"/>
               </a:rPr>
-              <a:t>Tipo II: 31</a:t>
+              <a:t>Tipo II: 30</a:t>
             </a:r>
           </a:p>
           <a:p>
@@ -3362,7 +3362,7 @@
                 </a:solidFill>
                 <a:latin typeface="Calibri"/>
               </a:rPr>
-              <a:t>Lima: 171</a:t>
+              <a:t>Lima: 169</a:t>
             </a:r>
           </a:p>
           <a:p>
@@ -3407,22 +3407,22 @@
                 </a:solidFill>
                 <a:latin typeface="Calibri"/>
               </a:rPr>
+              <a:t>Huaral: 2</a:t>
+            </a:r>
+          </a:p>
+          <a:p>
+            <a:pPr marL="0" indent="0">
+              <a:buFont typeface="Arial"/>
+              <a:buChar char="•"/>
+            </a:pPr>
+            <a:r>
+              <a:rPr lang="es-PE" sz="1200" dirty="0">
+                <a:solidFill>
+                  <a:srgbClr val="223344"/>
+                </a:solidFill>
+                <a:latin typeface="Calibri"/>
+              </a:rPr>
               <a:t>Barranca: 1</a:t>
-            </a:r>
-          </a:p>
-          <a:p>
-            <a:pPr marL="0" indent="0">
-              <a:buFont typeface="Arial"/>
-              <a:buChar char="•"/>
-            </a:pPr>
-            <a:r>
-              <a:rPr lang="es-PE" sz="1200" dirty="0">
-                <a:solidFill>
-                  <a:srgbClr val="223344"/>
-                </a:solidFill>
-                <a:latin typeface="Calibri"/>
-              </a:rPr>
-              <a:t>Huaral: 1</a:t>
             </a:r>
           </a:p>
           <a:p>
@@ -3586,7 +3586,7 @@
                 </a:solidFill>
                 <a:latin typeface="Calibri"/>
               </a:rPr>
-              <a:t>509 bancos de sangre autorizados en 25 regiones</a:t>
+              <a:t>506 bancos de sangre autorizados en 25 regiones</a:t>
             </a:r>
           </a:p>
           <a:p>
@@ -3601,7 +3601,7 @@
                 </a:solidFill>
                 <a:latin typeface="Calibri"/>
               </a:rPr>
-              <a:t>Tipo I-A: 320</a:t>
+              <a:t>Tipo I-A: 319</a:t>
             </a:r>
           </a:p>
           <a:p>
@@ -3631,7 +3631,7 @@
                 </a:solidFill>
                 <a:latin typeface="Calibri"/>
               </a:rPr>
-              <a:t>Tipo I-C: 22</a:t>
+              <a:t>Tipo I-C: 20</a:t>
             </a:r>
           </a:p>
           <a:p>
@@ -3660,7 +3660,7 @@
                 </a:solidFill>
                 <a:latin typeface="Calibri"/>
               </a:rPr>
-              <a:t>Lima concentra 179 (35 %); Arequipa 35 y La Libertad 33 le siguen.</a:t>
+              <a:t>Lima concentra 178 (35 %); Arequipa 37 y La Libertad 30 le siguen.</a:t>
             </a:r>
           </a:p>
           <a:p>
@@ -3795,7 +3795,7 @@
                 </a:solidFill>
                 <a:latin typeface="Calibri"/>
               </a:rPr>
-              <a:t>7 bancos de sangre</a:t>
+              <a:t>6 bancos de sangre</a:t>
             </a:r>
           </a:p>
           <a:p>
@@ -3810,7 +3810,7 @@
                 </a:solidFill>
                 <a:latin typeface="Calibri"/>
               </a:rPr>
-              <a:t>Tipo I-A: 5</a:t>
+              <a:t>Tipo I-A: 4</a:t>
             </a:r>
           </a:p>
           <a:p>
@@ -3884,7 +3884,7 @@
                 </a:solidFill>
                 <a:latin typeface="Calibri"/>
               </a:rPr>
-              <a:t>Maynas: 6</a:t>
+              <a:t>Maynas: 5</a:t>
             </a:r>
           </a:p>
           <a:p>
@@ -4792,7 +4792,7 @@
                 </a:solidFill>
                 <a:latin typeface="Calibri"/>
               </a:rPr>
-              <a:t>29 bancos de sangre</a:t>
+              <a:t>28 bancos de sangre</a:t>
             </a:r>
           </a:p>
           <a:p>
@@ -4852,7 +4852,7 @@
                 </a:solidFill>
                 <a:latin typeface="Calibri"/>
               </a:rPr>
-              <a:t>Tipo II: 5</a:t>
+              <a:t>Tipo II: 4</a:t>
             </a:r>
           </a:p>
           <a:p>
@@ -4896,7 +4896,7 @@
                 </a:solidFill>
                 <a:latin typeface="Calibri"/>
               </a:rPr>
-              <a:t>Sullana: 7</a:t>
+              <a:t>Sullana: 6</a:t>
             </a:r>
           </a:p>
           <a:p>
@@ -5373,7 +5373,7 @@
                 </a:solidFill>
                 <a:latin typeface="Calibri"/>
               </a:rPr>
-              <a:t>Tipo I-A: 14</a:t>
+              <a:t>Tipo I-A: 13</a:t>
             </a:r>
           </a:p>
           <a:p>
@@ -5388,7 +5388,7 @@
                 </a:solidFill>
                 <a:latin typeface="Calibri"/>
               </a:rPr>
-              <a:t>Tipo I-B: 6</a:t>
+              <a:t>Tipo I-B: 7</a:t>
             </a:r>
           </a:p>
           <a:p>
@@ -5701,7 +5701,7 @@
                 </a:solidFill>
                 <a:latin typeface="Calibri"/>
               </a:rPr>
-              <a:t>6 bancos de sangre</a:t>
+              <a:t>5 bancos de sangre</a:t>
             </a:r>
           </a:p>
           <a:p>
@@ -5716,7 +5716,7 @@
                 </a:solidFill>
                 <a:latin typeface="Calibri"/>
               </a:rPr>
-              <a:t>Tipo I-A: 4</a:t>
+              <a:t>Tipo I-A: 3</a:t>
             </a:r>
           </a:p>
           <a:p>
@@ -5790,7 +5790,7 @@
                 </a:solidFill>
                 <a:latin typeface="Calibri"/>
               </a:rPr>
-              <a:t>Tacna: 6</a:t>
+              <a:t>Tacna: 5</a:t>
             </a:r>
           </a:p>
           <a:p>
@@ -6177,7 +6177,7 @@
                 </a:solidFill>
                 <a:latin typeface="Calibri"/>
               </a:rPr>
-              <a:t>5 bancos de sangre</a:t>
+              <a:t>6 bancos de sangre</a:t>
             </a:r>
           </a:p>
           <a:p>
@@ -6192,7 +6192,7 @@
                 </a:solidFill>
                 <a:latin typeface="Calibri"/>
               </a:rPr>
-              <a:t>Tipo I-A: 4</a:t>
+              <a:t>Tipo I-A: 5</a:t>
             </a:r>
           </a:p>
           <a:p>
@@ -6266,7 +6266,7 @@
                 </a:solidFill>
                 <a:latin typeface="Calibri"/>
               </a:rPr>
-              <a:t>Coronel Portillo: 4</a:t>
+              <a:t>Coronel Portillo: 5</a:t>
             </a:r>
           </a:p>
           <a:p>
@@ -6741,6 +6741,44 @@
                         <a:rPr lang="es-PE" sz="900">
                           <a:latin typeface="Calibri"/>
                         </a:rPr>
+                        <a:t>2</a:t>
+                      </a:r>
+                    </a:p>
+                  </a:txBody>
+                  <a:tcPr marT="15000" marB="15000">
+                    <a:solidFill>
+                      <a:srgbClr val="EEF1F6"/>
+                    </a:solidFill>
+                  </a:tcPr>
+                </a:tc>
+                <a:tc>
+                  <a:txBody>
+                    <a:bodyPr/>
+                    <a:lstStyle/>
+                    <a:p>
+                      <a:r>
+                        <a:rPr lang="es-PE" sz="900">
+                          <a:latin typeface="Calibri"/>
+                        </a:rPr>
+                        <a:t>0</a:t>
+                      </a:r>
+                    </a:p>
+                  </a:txBody>
+                  <a:tcPr marT="15000" marB="15000">
+                    <a:solidFill>
+                      <a:srgbClr val="EEF1F6"/>
+                    </a:solidFill>
+                  </a:tcPr>
+                </a:tc>
+                <a:tc>
+                  <a:txBody>
+                    <a:bodyPr/>
+                    <a:lstStyle/>
+                    <a:p>
+                      <a:r>
+                        <a:rPr lang="es-PE" sz="900">
+                          <a:latin typeface="Calibri"/>
+                        </a:rPr>
                         <a:t>3</a:t>
                       </a:r>
                     </a:p>
@@ -6760,45 +6798,7 @@
                         <a:rPr lang="es-PE" sz="900">
                           <a:latin typeface="Calibri"/>
                         </a:rPr>
-                        <a:t>0</a:t>
-                      </a:r>
-                    </a:p>
-                  </a:txBody>
-                  <a:tcPr marT="15000" marB="15000">
-                    <a:solidFill>
-                      <a:srgbClr val="EEF1F6"/>
-                    </a:solidFill>
-                  </a:tcPr>
-                </a:tc>
-                <a:tc>
-                  <a:txBody>
-                    <a:bodyPr/>
-                    <a:lstStyle/>
-                    <a:p>
-                      <a:r>
-                        <a:rPr lang="es-PE" sz="900">
-                          <a:latin typeface="Calibri"/>
-                        </a:rPr>
-                        <a:t>3</a:t>
-                      </a:r>
-                    </a:p>
-                  </a:txBody>
-                  <a:tcPr marT="15000" marB="15000">
-                    <a:solidFill>
-                      <a:srgbClr val="EEF1F6"/>
-                    </a:solidFill>
-                  </a:tcPr>
-                </a:tc>
-                <a:tc>
-                  <a:txBody>
-                    <a:bodyPr/>
-                    <a:lstStyle/>
-                    <a:p>
-                      <a:r>
-                        <a:rPr lang="es-PE" sz="900">
-                          <a:latin typeface="Calibri"/>
-                        </a:rPr>
-                        <a:t>20</a:t>
+                        <a:t>19</a:t>
                       </a:r>
                     </a:p>
                   </a:txBody>
@@ -6964,7 +6964,7 @@
                         <a:rPr lang="es-PE" sz="900">
                           <a:latin typeface="Calibri"/>
                         </a:rPr>
-                        <a:t>27</a:t>
+                        <a:t>29</a:t>
                       </a:r>
                     </a:p>
                   </a:txBody>
@@ -7040,7 +7040,7 @@
                         <a:rPr lang="es-PE" sz="900">
                           <a:latin typeface="Calibri"/>
                         </a:rPr>
-                        <a:t>35</a:t>
+                        <a:t>37</a:t>
                       </a:r>
                     </a:p>
                   </a:txBody>
@@ -7085,7 +7085,7 @@
                         <a:rPr lang="es-PE" sz="900">
                           <a:latin typeface="Calibri"/>
                         </a:rPr>
-                        <a:t>8</a:t>
+                        <a:t>7</a:t>
                       </a:r>
                     </a:p>
                   </a:txBody>
@@ -7142,7 +7142,7 @@
                         <a:rPr lang="es-PE" sz="900">
                           <a:latin typeface="Calibri"/>
                         </a:rPr>
-                        <a:t>1</a:t>
+                        <a:t>2</a:t>
                       </a:r>
                     </a:p>
                   </a:txBody>
@@ -7206,7 +7206,7 @@
                         <a:rPr lang="es-PE" sz="900">
                           <a:latin typeface="Calibri"/>
                         </a:rPr>
-                        <a:t>17</a:t>
+                        <a:t>18</a:t>
                       </a:r>
                     </a:p>
                   </a:txBody>
@@ -7263,7 +7263,7 @@
                         <a:rPr lang="es-PE" sz="900">
                           <a:latin typeface="Calibri"/>
                         </a:rPr>
-                        <a:t>2</a:t>
+                        <a:t>3</a:t>
                       </a:r>
                     </a:p>
                   </a:txBody>
@@ -7282,7 +7282,7 @@
                         <a:rPr lang="es-PE" sz="900">
                           <a:latin typeface="Calibri"/>
                         </a:rPr>
-                        <a:t>22</a:t>
+                        <a:t>24</a:t>
                       </a:r>
                     </a:p>
                   </a:txBody>
@@ -7327,6 +7327,44 @@
                         <a:rPr lang="es-PE" sz="900">
                           <a:latin typeface="Calibri"/>
                         </a:rPr>
+                        <a:t>1</a:t>
+                      </a:r>
+                    </a:p>
+                  </a:txBody>
+                  <a:tcPr marT="15000" marB="15000">
+                    <a:solidFill>
+                      <a:srgbClr val="FFFFFF"/>
+                    </a:solidFill>
+                  </a:tcPr>
+                </a:tc>
+                <a:tc>
+                  <a:txBody>
+                    <a:bodyPr/>
+                    <a:lstStyle/>
+                    <a:p>
+                      <a:r>
+                        <a:rPr lang="es-PE" sz="900">
+                          <a:latin typeface="Calibri"/>
+                        </a:rPr>
+                        <a:t>3</a:t>
+                      </a:r>
+                    </a:p>
+                  </a:txBody>
+                  <a:tcPr marT="15000" marB="15000">
+                    <a:solidFill>
+                      <a:srgbClr val="FFFFFF"/>
+                    </a:solidFill>
+                  </a:tcPr>
+                </a:tc>
+                <a:tc>
+                  <a:txBody>
+                    <a:bodyPr/>
+                    <a:lstStyle/>
+                    <a:p>
+                      <a:r>
+                        <a:rPr lang="es-PE" sz="900">
+                          <a:latin typeface="Calibri"/>
+                        </a:rPr>
                         <a:t>2</a:t>
                       </a:r>
                     </a:p>
@@ -7365,45 +7403,7 @@
                         <a:rPr lang="es-PE" sz="900">
                           <a:latin typeface="Calibri"/>
                         </a:rPr>
-                        <a:t>2</a:t>
-                      </a:r>
-                    </a:p>
-                  </a:txBody>
-                  <a:tcPr marT="15000" marB="15000">
-                    <a:solidFill>
-                      <a:srgbClr val="FFFFFF"/>
-                    </a:solidFill>
-                  </a:tcPr>
-                </a:tc>
-                <a:tc>
-                  <a:txBody>
-                    <a:bodyPr/>
-                    <a:lstStyle/>
-                    <a:p>
-                      <a:r>
-                        <a:rPr lang="es-PE" sz="900">
-                          <a:latin typeface="Calibri"/>
-                        </a:rPr>
-                        <a:t>4</a:t>
-                      </a:r>
-                    </a:p>
-                  </a:txBody>
-                  <a:tcPr marT="15000" marB="15000">
-                    <a:solidFill>
-                      <a:srgbClr val="FFFFFF"/>
-                    </a:solidFill>
-                  </a:tcPr>
-                </a:tc>
-                <a:tc>
-                  <a:txBody>
-                    <a:bodyPr/>
-                    <a:lstStyle/>
-                    <a:p>
-                      <a:r>
-                        <a:rPr lang="es-PE" sz="900">
-                          <a:latin typeface="Calibri"/>
-                        </a:rPr>
-                        <a:t>11</a:t>
+                        <a:t>9</a:t>
                       </a:r>
                     </a:p>
                   </a:txBody>
@@ -7690,7 +7690,7 @@
                         <a:rPr lang="es-PE" sz="900">
                           <a:latin typeface="Calibri"/>
                         </a:rPr>
-                        <a:t>7</a:t>
+                        <a:t>6</a:t>
                       </a:r>
                     </a:p>
                   </a:txBody>
@@ -7766,7 +7766,7 @@
                         <a:rPr lang="es-PE" sz="900">
                           <a:latin typeface="Calibri"/>
                         </a:rPr>
-                        <a:t>10</a:t>
+                        <a:t>9</a:t>
                       </a:r>
                     </a:p>
                   </a:txBody>
@@ -7932,7 +7932,7 @@
                         <a:rPr lang="es-PE" sz="900">
                           <a:latin typeface="Calibri"/>
                         </a:rPr>
-                        <a:t>11</a:t>
+                        <a:t>13</a:t>
                       </a:r>
                     </a:p>
                   </a:txBody>
@@ -7989,7 +7989,7 @@
                         <a:rPr lang="es-PE" sz="900">
                           <a:latin typeface="Calibri"/>
                         </a:rPr>
-                        <a:t>4</a:t>
+                        <a:t>5</a:t>
                       </a:r>
                     </a:p>
                   </a:txBody>
@@ -8008,7 +8008,7 @@
                         <a:rPr lang="es-PE" sz="900">
                           <a:latin typeface="Calibri"/>
                         </a:rPr>
-                        <a:t>20</a:t>
+                        <a:t>23</a:t>
                       </a:r>
                     </a:p>
                   </a:txBody>
@@ -8053,7 +8053,7 @@
                         <a:rPr lang="es-PE" sz="900">
                           <a:latin typeface="Calibri"/>
                         </a:rPr>
-                        <a:t>20</a:t>
+                        <a:t>18</a:t>
                       </a:r>
                     </a:p>
                   </a:txBody>
@@ -8091,7 +8091,7 @@
                         <a:rPr lang="es-PE" sz="900">
                           <a:latin typeface="Calibri"/>
                         </a:rPr>
-                        <a:t>2</a:t>
+                        <a:t>1</a:t>
                       </a:r>
                     </a:p>
                   </a:txBody>
@@ -8129,7 +8129,7 @@
                         <a:rPr lang="es-PE" sz="900">
                           <a:latin typeface="Calibri"/>
                         </a:rPr>
-                        <a:t>33</a:t>
+                        <a:t>30</a:t>
                       </a:r>
                     </a:p>
                   </a:txBody>
@@ -8295,7 +8295,7 @@
                         <a:rPr lang="es-PE" sz="900">
                           <a:latin typeface="Calibri"/>
                         </a:rPr>
-                        <a:t>103</a:t>
+                        <a:t>104</a:t>
                       </a:r>
                     </a:p>
                   </a:txBody>
@@ -8333,7 +8333,7 @@
                         <a:rPr lang="es-PE" sz="900">
                           <a:latin typeface="Calibri"/>
                         </a:rPr>
-                        <a:t>11</a:t>
+                        <a:t>10</a:t>
                       </a:r>
                     </a:p>
                   </a:txBody>
@@ -8352,7 +8352,7 @@
                         <a:rPr lang="es-PE" sz="900">
                           <a:latin typeface="Calibri"/>
                         </a:rPr>
-                        <a:t>31</a:t>
+                        <a:t>30</a:t>
                       </a:r>
                     </a:p>
                   </a:txBody>
@@ -8371,7 +8371,7 @@
                         <a:rPr lang="es-PE" sz="900">
                           <a:latin typeface="Calibri"/>
                         </a:rPr>
-                        <a:t>179</a:t>
+                        <a:t>178</a:t>
                       </a:r>
                     </a:p>
                   </a:txBody>
@@ -8416,7 +8416,7 @@
                         <a:rPr lang="es-PE" sz="900">
                           <a:latin typeface="Calibri"/>
                         </a:rPr>
-                        <a:t>5</a:t>
+                        <a:t>4</a:t>
                       </a:r>
                     </a:p>
                   </a:txBody>
@@ -8492,7 +8492,7 @@
                         <a:rPr lang="es-PE" sz="900">
                           <a:latin typeface="Calibri"/>
                         </a:rPr>
-                        <a:t>7</a:t>
+                        <a:t>6</a:t>
                       </a:r>
                     </a:p>
                   </a:txBody>
@@ -8957,7 +8957,7 @@
                         <a:rPr lang="es-PE" sz="900">
                           <a:latin typeface="Calibri"/>
                         </a:rPr>
-                        <a:t>5</a:t>
+                        <a:t>4</a:t>
                       </a:r>
                     </a:p>
                   </a:txBody>
@@ -8976,7 +8976,7 @@
                         <a:rPr lang="es-PE" sz="900">
                           <a:latin typeface="Calibri"/>
                         </a:rPr>
-                        <a:t>29</a:t>
+                        <a:t>28</a:t>
                       </a:r>
                     </a:p>
                   </a:txBody>
@@ -9142,7 +9142,7 @@
                         <a:rPr lang="es-PE" sz="900">
                           <a:latin typeface="Calibri"/>
                         </a:rPr>
-                        <a:t>14</a:t>
+                        <a:t>13</a:t>
                       </a:r>
                     </a:p>
                   </a:txBody>
@@ -9161,7 +9161,7 @@
                         <a:rPr lang="es-PE" sz="900">
                           <a:latin typeface="Calibri"/>
                         </a:rPr>
-                        <a:t>6</a:t>
+                        <a:t>7</a:t>
                       </a:r>
                     </a:p>
                   </a:txBody>
@@ -9263,7 +9263,7 @@
                         <a:rPr lang="es-PE" sz="900">
                           <a:latin typeface="Calibri"/>
                         </a:rPr>
-                        <a:t>4</a:t>
+                        <a:t>3</a:t>
                       </a:r>
                     </a:p>
                   </a:txBody>
@@ -9339,7 +9339,7 @@
                         <a:rPr lang="es-PE" sz="900">
                           <a:latin typeface="Calibri"/>
                         </a:rPr>
-                        <a:t>6</a:t>
+                        <a:t>5</a:t>
                       </a:r>
                     </a:p>
                   </a:txBody>
@@ -9505,7 +9505,7 @@
                         <a:rPr lang="es-PE" sz="900">
                           <a:latin typeface="Calibri"/>
                         </a:rPr>
-                        <a:t>4</a:t>
+                        <a:t>5</a:t>
                       </a:r>
                     </a:p>
                   </a:txBody>
@@ -9581,7 +9581,7 @@
                         <a:rPr lang="es-PE" sz="900">
                           <a:latin typeface="Calibri"/>
                         </a:rPr>
-                        <a:t>5</a:t>
+                        <a:t>6</a:t>
                       </a:r>
                     </a:p>
                   </a:txBody>
@@ -9626,7 +9626,7 @@
                         <a:rPr lang="es-PE" sz="900" b="1">
                           <a:latin typeface="Calibri"/>
                         </a:rPr>
-                        <a:t>320</a:t>
+                        <a:t>319</a:t>
                       </a:r>
                     </a:p>
                   </a:txBody>
@@ -9664,7 +9664,7 @@
                         <a:rPr lang="es-PE" sz="900" b="1">
                           <a:latin typeface="Calibri"/>
                         </a:rPr>
-                        <a:t>22</a:t>
+                        <a:t>20</a:t>
                       </a:r>
                     </a:p>
                   </a:txBody>
@@ -9702,7 +9702,7 @@
                         <a:rPr lang="es-PE" sz="900" b="1">
                           <a:latin typeface="Calibri"/>
                         </a:rPr>
-                        <a:t>509</a:t>
+                        <a:t>506</a:t>
                       </a:r>
                     </a:p>
                   </a:txBody>
@@ -9838,7 +9838,7 @@
                 </a:solidFill>
                 <a:latin typeface="Calibri"/>
               </a:rPr>
-              <a:t>169 de los 179 bancos de Lima están en esta área</a:t>
+              <a:t>168 de los 178 bancos de Lima están en esta área</a:t>
             </a:r>
           </a:p>
           <a:p>
@@ -9853,7 +9853,7 @@
                 </a:solidFill>
                 <a:latin typeface="Calibri"/>
               </a:rPr>
-              <a:t>Tipo I-A: 99</a:t>
+              <a:t>Tipo I-A: 100</a:t>
             </a:r>
           </a:p>
           <a:p>
@@ -9883,7 +9883,7 @@
                 </a:solidFill>
                 <a:latin typeface="Calibri"/>
               </a:rPr>
-              <a:t>Tipo I-C: 10</a:t>
+              <a:t>Tipo I-C: 9</a:t>
             </a:r>
           </a:p>
           <a:p>
@@ -9898,7 +9898,7 @@
                 </a:solidFill>
                 <a:latin typeface="Calibri"/>
               </a:rPr>
-              <a:t>Tipo II: 29</a:t>
+              <a:t>Tipo II: 28</a:t>
             </a:r>
           </a:p>
           <a:p>
@@ -10010,7 +10010,7 @@
                 </a:solidFill>
                 <a:latin typeface="Calibri"/>
               </a:rPr>
-              <a:t>Bancos de sangre: Registro Nacional de Bancos de Sangre Autorizados (hojas BS I A, BS I B, BS I C y BS II), 509 establecimientos.</a:t>
+              <a:t>Bancos de sangre: Matriz General de Autorización Sanitaria DIBAN; solo se consideran los establecimientos con estado AUTORIZADO (506 bancos).</a:t>
             </a:r>
           </a:p>
           <a:p>
@@ -10025,7 +10025,7 @@
                 </a:solidFill>
                 <a:latin typeface="Calibri"/>
               </a:rPr>
-              <a:t>Coordenadas aproximadas al centro del distrito declarado; no corresponden a la dirección exacta.</a:t>
+              <a:t>Ubicación: 476 bancos se ubican por su código RENIPRESS o inscripción en el Registro Nacional; 30 por nombre o por el centro de su distrito. Son coordenadas aproximadas, no la dirección exacta.</a:t>
             </a:r>
           </a:p>
           <a:p>
@@ -10544,7 +10544,7 @@
                 </a:solidFill>
                 <a:latin typeface="Calibri"/>
               </a:rPr>
-              <a:t>20 bancos de sangre</a:t>
+              <a:t>19 bancos de sangre</a:t>
             </a:r>
           </a:p>
           <a:p>
@@ -10574,7 +10574,7 @@
                 </a:solidFill>
                 <a:latin typeface="Calibri"/>
               </a:rPr>
-              <a:t>Tipo I-B: 3</a:t>
+              <a:t>Tipo I-B: 2</a:t>
             </a:r>
           </a:p>
           <a:p>
@@ -10648,7 +10648,7 @@
                 </a:solidFill>
                 <a:latin typeface="Calibri"/>
               </a:rPr>
-              <a:t>Huaraz: 4</a:t>
+              <a:t>Huaraz: 3</a:t>
             </a:r>
           </a:p>
           <a:p>
@@ -11185,7 +11185,7 @@
                 </a:solidFill>
                 <a:latin typeface="Calibri"/>
               </a:rPr>
-              <a:t>35 bancos de sangre</a:t>
+              <a:t>37 bancos de sangre</a:t>
             </a:r>
           </a:p>
           <a:p>
@@ -11200,7 +11200,7 @@
                 </a:solidFill>
                 <a:latin typeface="Calibri"/>
               </a:rPr>
-              <a:t>Tipo I-A: 27</a:t>
+              <a:t>Tipo I-A: 29</a:t>
             </a:r>
           </a:p>
           <a:p>
@@ -11274,7 +11274,7 @@
                 </a:solidFill>
                 <a:latin typeface="Calibri"/>
               </a:rPr>
-              <a:t>Arequipa: 31</a:t>
+              <a:t>Arequipa: 33</a:t>
             </a:r>
           </a:p>
           <a:p>
@@ -11483,7 +11483,7 @@
                 </a:solidFill>
                 <a:latin typeface="Calibri"/>
               </a:rPr>
-              <a:t>Tipo I-A: 8</a:t>
+              <a:t>Tipo I-A: 7</a:t>
             </a:r>
           </a:p>
           <a:p>
@@ -11528,7 +11528,7 @@
                 </a:solidFill>
                 <a:latin typeface="Calibri"/>
               </a:rPr>
-              <a:t>Tipo II: 1</a:t>
+              <a:t>Tipo II: 2</a:t>
             </a:r>
           </a:p>
           <a:p>

</xml_diff>